<commit_message>
Statistics refresher: five-question in-class quiz
Co-Authored-By: Claude Opus 5.5 <noreply@anthropic.com>
Claude-Session: https://claude.ai/code/session_01TbrdxHn7W6FVXXnpqzNytd
</commit_message>
<xml_diff>
--- a/slides/01b_statistics-refresher_WT26-27.pptx
+++ b/slides/01b_statistics-refresher_WT26-27.pptx
@@ -40,6 +40,7 @@
     <p:sldId id="282" r:id="rId39"/>
     <p:sldId id="283" r:id="rId40"/>
     <p:sldId id="284" r:id="rId41"/>
+    <p:sldId id="285" r:id="rId42"/>
   </p:sldIdLst>
   <p:sldSz cx="9144000" cy="5715000" type="screen16x10"/>
   <p:notesSz cx="6858000" cy="9144000"/>
@@ -2161,7 +2162,7 @@
           <a:lstStyle/>
           <a:p>
             <a:r>
-              <a:t>The vocabulary for the rest of the course: every regression table reports means, standard errors, z- or t-values and builds on covariances.</a:t>
+              <a:t>Three minutes alone, then compare with your neighbour; reveal the answers one by one. Answers: 1 B (ordinal: ordered, but the distances between stars are unknown). 2 B (the median, 12; the event day pulls the mean to 20). 3 A (SE = sd / square root of n: four times the sample halves it). 4 B (z counts standard deviations; about 2.3 % of weeks lie that low in a normal distribution, so C is wrong). 5 B (r measures the strength of a straight-line relationship; it says nothing about cause, and the slope per euro is the regression coefficient, -34 bars here).</a:t>
             </a:r>
           </a:p>
         </p:txBody>
@@ -2231,7 +2232,7 @@
           <a:lstStyle/>
           <a:p>
             <a:r>
-              <a:t>Field is the friendliest textbook for students without a statistics background; Seeing Theory and StatQuest visualise every concept of today.</a:t>
+              <a:t>The vocabulary for the rest of the course: every regression table reports means, standard errors, z- or t-values and builds on covariances.</a:t>
             </a:r>
           </a:p>
         </p:txBody>
@@ -2301,7 +2302,7 @@
           <a:lstStyle/>
           <a:p>
             <a:r>
-              <a:t>Questions? Contact details on the card; office hours via the booking link.</a:t>
+              <a:t>Field is the friendliest textbook for students without a statistics background; Seeing Theory and StatQuest visualise every concept of today.</a:t>
             </a:r>
           </a:p>
         </p:txBody>
@@ -2372,6 +2373,76 @@
           <a:p>
             <a:r>
               <a:t>A kiosk at the university sells one chocolate bar. Over five weeks the owner tried five prices. Small numbers on purpose: every result today can be checked with a calculator. The daily sales of one week (right) serve for mean and median.</a:t>
+            </a:r>
+          </a:p>
+        </p:txBody>
+      </p:sp>
+      <p:sp>
+        <p:nvSpPr>
+          <p:cNvPr id="4" name="Slide Number Placeholder 3"/>
+          <p:cNvSpPr>
+            <a:spLocks noGrp="1"/>
+          </p:cNvSpPr>
+          <p:nvPr>
+            <p:ph type="sldNum" idx="5" sz="quarter"/>
+          </p:nvPr>
+        </p:nvSpPr>
+        <p:spPr/>
+      </p:sp>
+    </p:spTree>
+  </p:cSld>
+  <p:clrMapOvr>
+    <a:masterClrMapping/>
+  </p:clrMapOvr>
+</p:notes>
+</file>
+
+<file path=ppt/notesSlides/notesSlide30.xml><?xml version="1.0" encoding="utf-8"?>
+<p:notes xmlns:a="http://schemas.openxmlformats.org/drawingml/2006/main" xmlns:p="http://schemas.openxmlformats.org/presentationml/2006/main" xmlns:r="http://schemas.openxmlformats.org/officeDocument/2006/relationships">
+  <p:cSld>
+    <p:spTree>
+      <p:nvGrpSpPr>
+        <p:cNvPr id="1" name=""/>
+        <p:cNvGrpSpPr/>
+        <p:nvPr/>
+      </p:nvGrpSpPr>
+      <p:grpSpPr>
+        <a:xfrm>
+          <a:off x="0" y="0"/>
+          <a:ext cx="0" cy="0"/>
+          <a:chOff x="0" y="0"/>
+          <a:chExt cx="0" cy="0"/>
+        </a:xfrm>
+      </p:grpSpPr>
+      <p:sp>
+        <p:nvSpPr>
+          <p:cNvPr id="2" name="Slide Image Placeholder 1"/>
+          <p:cNvSpPr>
+            <a:spLocks noGrp="1"/>
+          </p:cNvSpPr>
+          <p:nvPr>
+            <p:ph type="sldImg" idx="2"/>
+          </p:nvPr>
+        </p:nvSpPr>
+        <p:spPr/>
+      </p:sp>
+      <p:sp>
+        <p:nvSpPr>
+          <p:cNvPr id="3" name="Notes Placeholder 2"/>
+          <p:cNvSpPr>
+            <a:spLocks noGrp="1"/>
+          </p:cNvSpPr>
+          <p:nvPr>
+            <p:ph type="body" idx="3" sz="quarter"/>
+          </p:nvPr>
+        </p:nvSpPr>
+        <p:spPr/>
+        <p:txBody>
+          <a:bodyPr/>
+          <a:lstStyle/>
+          <a:p>
+            <a:r>
+              <a:t>Questions? Contact details on the card; office hours via the booking link.</a:t>
             </a:r>
           </a:p>
         </p:txBody>
@@ -30337,7 +30408,7 @@
           <a:p>
             <a:r>
               <a:rPr sz="1600" lang="en-GB"/>
-              <a:t>Key takeaways</a:t>
+              <a:t>In-class quiz: five questions</a:t>
             </a:r>
           </a:p>
         </p:txBody>
@@ -30393,7 +30464,7 @@
       </p:sp>
       <p:sp>
         <p:nvSpPr>
-          <p:cNvPr id="10" name="Takeaways row 1"/>
+          <p:cNvPr id="10" name="Quiz row 1"/>
           <p:cNvSpPr/>
           <p:nvPr/>
         </p:nvSpPr>
@@ -30435,16 +30506,659 @@
       </p:sp>
       <p:sp>
         <p:nvSpPr>
-          <p:cNvPr id="11" name="Takeaways number 1"/>
+          <p:cNvPr id="11" name="Quiz bar 1"/>
           <p:cNvSpPr/>
           <p:nvPr/>
         </p:nvSpPr>
         <p:spPr>
           <a:xfrm>
-            <a:off x="594360" y="1371600"/>
-            <a:ext cx="310896" cy="310896"/>
-          </a:xfrm>
-          <a:prstGeom prst="ellipse">
+            <a:off x="457200" y="1234440"/>
+            <a:ext cx="64008" cy="585216"/>
+          </a:xfrm>
+          <a:prstGeom prst="rect">
+            <a:avLst/>
+          </a:prstGeom>
+          <a:solidFill>
+            <a:schemeClr val="accent1"/>
+          </a:solidFill>
+          <a:ln>
+            <a:noFill/>
+          </a:ln>
+          <a:effectLst/>
+        </p:spPr>
+        <p:style>
+          <a:lnRef idx="1">
+            <a:schemeClr val="accent1"/>
+          </a:lnRef>
+          <a:fillRef idx="3">
+            <a:schemeClr val="accent1"/>
+          </a:fillRef>
+          <a:effectRef idx="2">
+            <a:schemeClr val="accent1"/>
+          </a:effectRef>
+          <a:fontRef idx="minor">
+            <a:schemeClr val="lt1"/>
+          </a:fontRef>
+        </p:style>
+        <p:txBody>
+          <a:bodyPr rtlCol="0" anchor="ctr"/>
+          <a:lstStyle/>
+          <a:p/>
+        </p:txBody>
+      </p:sp>
+      <p:sp>
+        <p:nvSpPr>
+          <p:cNvPr id="12" name="Quiz text 1"/>
+          <p:cNvSpPr txBox="1"/>
+          <p:nvPr/>
+        </p:nvSpPr>
+        <p:spPr>
+          <a:xfrm>
+            <a:off x="658368" y="1234440"/>
+            <a:ext cx="7955280" cy="585216"/>
+          </a:xfrm>
+          <a:prstGeom prst="rect">
+            <a:avLst/>
+          </a:prstGeom>
+          <a:noFill/>
+        </p:spPr>
+        <p:txBody>
+          <a:bodyPr wrap="square" lIns="0" rIns="0" tIns="0" bIns="0" anchor="ctr">
+            <a:noAutofit/>
+          </a:bodyPr>
+          <a:lstStyle/>
+          <a:p>
+            <a:pPr algn="l">
+              <a:spcAft>
+                <a:spcPts val="100"/>
+              </a:spcAft>
+            </a:pPr>
+            <a:r>
+              <a:rPr sz="1200" b="1" lang="en-GB">
+                <a:solidFill>
+                  <a:schemeClr val="tx2"/>
+                </a:solidFill>
+              </a:rPr>
+              <a:t>1 Satisfaction from 1 to 5 stars is measured on which scale?</a:t>
+            </a:r>
+          </a:p>
+          <a:p>
+            <a:pPr algn="l">
+              <a:spcAft>
+                <a:spcPts val="100"/>
+              </a:spcAft>
+            </a:pPr>
+            <a:r>
+              <a:rPr sz="1200" b="0" lang="en-GB">
+                <a:solidFill>
+                  <a:schemeClr val="tx1"/>
+                </a:solidFill>
+              </a:rPr>
+              <a:t>A nominal     B ordinal     C ratio</a:t>
+            </a:r>
+          </a:p>
+        </p:txBody>
+      </p:sp>
+      <p:sp>
+        <p:nvSpPr>
+          <p:cNvPr id="13" name="Quiz row 2"/>
+          <p:cNvSpPr/>
+          <p:nvPr/>
+        </p:nvSpPr>
+        <p:spPr>
+          <a:xfrm>
+            <a:off x="457200" y="1892808"/>
+            <a:ext cx="8229600" cy="585216"/>
+          </a:xfrm>
+          <a:prstGeom prst="rect">
+            <a:avLst/>
+          </a:prstGeom>
+          <a:solidFill>
+            <a:schemeClr val="bg2"/>
+          </a:solidFill>
+          <a:ln>
+            <a:noFill/>
+          </a:ln>
+          <a:effectLst/>
+        </p:spPr>
+        <p:style>
+          <a:lnRef idx="1">
+            <a:schemeClr val="accent1"/>
+          </a:lnRef>
+          <a:fillRef idx="3">
+            <a:schemeClr val="accent1"/>
+          </a:fillRef>
+          <a:effectRef idx="2">
+            <a:schemeClr val="accent1"/>
+          </a:effectRef>
+          <a:fontRef idx="minor">
+            <a:schemeClr val="lt1"/>
+          </a:fontRef>
+        </p:style>
+        <p:txBody>
+          <a:bodyPr rtlCol="0" anchor="ctr"/>
+          <a:lstStyle/>
+          <a:p/>
+        </p:txBody>
+      </p:sp>
+      <p:sp>
+        <p:nvSpPr>
+          <p:cNvPr id="14" name="Quiz bar 2"/>
+          <p:cNvSpPr/>
+          <p:nvPr/>
+        </p:nvSpPr>
+        <p:spPr>
+          <a:xfrm>
+            <a:off x="457200" y="1892808"/>
+            <a:ext cx="64008" cy="585216"/>
+          </a:xfrm>
+          <a:prstGeom prst="rect">
+            <a:avLst/>
+          </a:prstGeom>
+          <a:solidFill>
+            <a:schemeClr val="accent1"/>
+          </a:solidFill>
+          <a:ln>
+            <a:noFill/>
+          </a:ln>
+          <a:effectLst/>
+        </p:spPr>
+        <p:style>
+          <a:lnRef idx="1">
+            <a:schemeClr val="accent1"/>
+          </a:lnRef>
+          <a:fillRef idx="3">
+            <a:schemeClr val="accent1"/>
+          </a:fillRef>
+          <a:effectRef idx="2">
+            <a:schemeClr val="accent1"/>
+          </a:effectRef>
+          <a:fontRef idx="minor">
+            <a:schemeClr val="lt1"/>
+          </a:fontRef>
+        </p:style>
+        <p:txBody>
+          <a:bodyPr rtlCol="0" anchor="ctr"/>
+          <a:lstStyle/>
+          <a:p/>
+        </p:txBody>
+      </p:sp>
+      <p:sp>
+        <p:nvSpPr>
+          <p:cNvPr id="15" name="Quiz text 2"/>
+          <p:cNvSpPr txBox="1"/>
+          <p:nvPr/>
+        </p:nvSpPr>
+        <p:spPr>
+          <a:xfrm>
+            <a:off x="658368" y="1892808"/>
+            <a:ext cx="7955280" cy="585216"/>
+          </a:xfrm>
+          <a:prstGeom prst="rect">
+            <a:avLst/>
+          </a:prstGeom>
+          <a:noFill/>
+        </p:spPr>
+        <p:txBody>
+          <a:bodyPr wrap="square" lIns="0" rIns="0" tIns="0" bIns="0" anchor="ctr">
+            <a:noAutofit/>
+          </a:bodyPr>
+          <a:lstStyle/>
+          <a:p>
+            <a:pPr algn="l">
+              <a:spcAft>
+                <a:spcPts val="100"/>
+              </a:spcAft>
+            </a:pPr>
+            <a:r>
+              <a:rPr sz="1200" b="1" lang="en-GB">
+                <a:solidFill>
+                  <a:schemeClr val="tx2"/>
+                </a:solidFill>
+              </a:rPr>
+              <a:t>2 Daily sales 10, 12, 11, 13, 54: what describes a typical day best?</a:t>
+            </a:r>
+          </a:p>
+          <a:p>
+            <a:pPr algn="l">
+              <a:spcAft>
+                <a:spcPts val="100"/>
+              </a:spcAft>
+            </a:pPr>
+            <a:r>
+              <a:rPr sz="1200" b="0" lang="en-GB">
+                <a:solidFill>
+                  <a:schemeClr val="tx1"/>
+                </a:solidFill>
+              </a:rPr>
+              <a:t>A the mean (20)     B the median (12)     C the standard deviation</a:t>
+            </a:r>
+          </a:p>
+        </p:txBody>
+      </p:sp>
+      <p:sp>
+        <p:nvSpPr>
+          <p:cNvPr id="16" name="Quiz row 3"/>
+          <p:cNvSpPr/>
+          <p:nvPr/>
+        </p:nvSpPr>
+        <p:spPr>
+          <a:xfrm>
+            <a:off x="457200" y="2551176"/>
+            <a:ext cx="8229600" cy="585216"/>
+          </a:xfrm>
+          <a:prstGeom prst="rect">
+            <a:avLst/>
+          </a:prstGeom>
+          <a:solidFill>
+            <a:schemeClr val="bg2"/>
+          </a:solidFill>
+          <a:ln>
+            <a:noFill/>
+          </a:ln>
+          <a:effectLst/>
+        </p:spPr>
+        <p:style>
+          <a:lnRef idx="1">
+            <a:schemeClr val="accent1"/>
+          </a:lnRef>
+          <a:fillRef idx="3">
+            <a:schemeClr val="accent1"/>
+          </a:fillRef>
+          <a:effectRef idx="2">
+            <a:schemeClr val="accent1"/>
+          </a:effectRef>
+          <a:fontRef idx="minor">
+            <a:schemeClr val="lt1"/>
+          </a:fontRef>
+        </p:style>
+        <p:txBody>
+          <a:bodyPr rtlCol="0" anchor="ctr"/>
+          <a:lstStyle/>
+          <a:p/>
+        </p:txBody>
+      </p:sp>
+      <p:sp>
+        <p:nvSpPr>
+          <p:cNvPr id="17" name="Quiz bar 3"/>
+          <p:cNvSpPr/>
+          <p:nvPr/>
+        </p:nvSpPr>
+        <p:spPr>
+          <a:xfrm>
+            <a:off x="457200" y="2551176"/>
+            <a:ext cx="64008" cy="585216"/>
+          </a:xfrm>
+          <a:prstGeom prst="rect">
+            <a:avLst/>
+          </a:prstGeom>
+          <a:solidFill>
+            <a:schemeClr val="accent1"/>
+          </a:solidFill>
+          <a:ln>
+            <a:noFill/>
+          </a:ln>
+          <a:effectLst/>
+        </p:spPr>
+        <p:style>
+          <a:lnRef idx="1">
+            <a:schemeClr val="accent1"/>
+          </a:lnRef>
+          <a:fillRef idx="3">
+            <a:schemeClr val="accent1"/>
+          </a:fillRef>
+          <a:effectRef idx="2">
+            <a:schemeClr val="accent1"/>
+          </a:effectRef>
+          <a:fontRef idx="minor">
+            <a:schemeClr val="lt1"/>
+          </a:fontRef>
+        </p:style>
+        <p:txBody>
+          <a:bodyPr rtlCol="0" anchor="ctr"/>
+          <a:lstStyle/>
+          <a:p/>
+        </p:txBody>
+      </p:sp>
+      <p:sp>
+        <p:nvSpPr>
+          <p:cNvPr id="18" name="Quiz text 3"/>
+          <p:cNvSpPr txBox="1"/>
+          <p:nvPr/>
+        </p:nvSpPr>
+        <p:spPr>
+          <a:xfrm>
+            <a:off x="658368" y="2551176"/>
+            <a:ext cx="7955280" cy="585216"/>
+          </a:xfrm>
+          <a:prstGeom prst="rect">
+            <a:avLst/>
+          </a:prstGeom>
+          <a:noFill/>
+        </p:spPr>
+        <p:txBody>
+          <a:bodyPr wrap="square" lIns="0" rIns="0" tIns="0" bIns="0" anchor="ctr">
+            <a:noAutofit/>
+          </a:bodyPr>
+          <a:lstStyle/>
+          <a:p>
+            <a:pPr algn="l">
+              <a:spcAft>
+                <a:spcPts val="100"/>
+              </a:spcAft>
+            </a:pPr>
+            <a:r>
+              <a:rPr sz="1200" b="1" lang="en-GB">
+                <a:solidFill>
+                  <a:schemeClr val="tx2"/>
+                </a:solidFill>
+              </a:rPr>
+              <a:t>3 You survey four times as many customers. The standard error of the mean …</a:t>
+            </a:r>
+          </a:p>
+          <a:p>
+            <a:pPr algn="l">
+              <a:spcAft>
+                <a:spcPts val="100"/>
+              </a:spcAft>
+            </a:pPr>
+            <a:r>
+              <a:rPr sz="1200" b="0" lang="en-GB">
+                <a:solidFill>
+                  <a:schemeClr val="tx1"/>
+                </a:solidFill>
+              </a:rPr>
+              <a:t>A halves     B falls to a quarter     C stays the same</a:t>
+            </a:r>
+          </a:p>
+        </p:txBody>
+      </p:sp>
+      <p:sp>
+        <p:nvSpPr>
+          <p:cNvPr id="19" name="Quiz row 4"/>
+          <p:cNvSpPr/>
+          <p:nvPr/>
+        </p:nvSpPr>
+        <p:spPr>
+          <a:xfrm>
+            <a:off x="457200" y="3209544"/>
+            <a:ext cx="8229600" cy="585216"/>
+          </a:xfrm>
+          <a:prstGeom prst="rect">
+            <a:avLst/>
+          </a:prstGeom>
+          <a:solidFill>
+            <a:schemeClr val="bg2"/>
+          </a:solidFill>
+          <a:ln>
+            <a:noFill/>
+          </a:ln>
+          <a:effectLst/>
+        </p:spPr>
+        <p:style>
+          <a:lnRef idx="1">
+            <a:schemeClr val="accent1"/>
+          </a:lnRef>
+          <a:fillRef idx="3">
+            <a:schemeClr val="accent1"/>
+          </a:fillRef>
+          <a:effectRef idx="2">
+            <a:schemeClr val="accent1"/>
+          </a:effectRef>
+          <a:fontRef idx="minor">
+            <a:schemeClr val="lt1"/>
+          </a:fontRef>
+        </p:style>
+        <p:txBody>
+          <a:bodyPr rtlCol="0" anchor="ctr"/>
+          <a:lstStyle/>
+          <a:p/>
+        </p:txBody>
+      </p:sp>
+      <p:sp>
+        <p:nvSpPr>
+          <p:cNvPr id="20" name="Quiz bar 4"/>
+          <p:cNvSpPr/>
+          <p:nvPr/>
+        </p:nvSpPr>
+        <p:spPr>
+          <a:xfrm>
+            <a:off x="457200" y="3209544"/>
+            <a:ext cx="64008" cy="585216"/>
+          </a:xfrm>
+          <a:prstGeom prst="rect">
+            <a:avLst/>
+          </a:prstGeom>
+          <a:solidFill>
+            <a:schemeClr val="accent1"/>
+          </a:solidFill>
+          <a:ln>
+            <a:noFill/>
+          </a:ln>
+          <a:effectLst/>
+        </p:spPr>
+        <p:style>
+          <a:lnRef idx="1">
+            <a:schemeClr val="accent1"/>
+          </a:lnRef>
+          <a:fillRef idx="3">
+            <a:schemeClr val="accent1"/>
+          </a:fillRef>
+          <a:effectRef idx="2">
+            <a:schemeClr val="accent1"/>
+          </a:effectRef>
+          <a:fontRef idx="minor">
+            <a:schemeClr val="lt1"/>
+          </a:fontRef>
+        </p:style>
+        <p:txBody>
+          <a:bodyPr rtlCol="0" anchor="ctr"/>
+          <a:lstStyle/>
+          <a:p/>
+        </p:txBody>
+      </p:sp>
+      <p:sp>
+        <p:nvSpPr>
+          <p:cNvPr id="21" name="Quiz text 4"/>
+          <p:cNvSpPr txBox="1"/>
+          <p:nvPr/>
+        </p:nvSpPr>
+        <p:spPr>
+          <a:xfrm>
+            <a:off x="658368" y="3209544"/>
+            <a:ext cx="7955280" cy="585216"/>
+          </a:xfrm>
+          <a:prstGeom prst="rect">
+            <a:avLst/>
+          </a:prstGeom>
+          <a:noFill/>
+        </p:spPr>
+        <p:txBody>
+          <a:bodyPr wrap="square" lIns="0" rIns="0" tIns="0" bIns="0" anchor="ctr">
+            <a:noAutofit/>
+          </a:bodyPr>
+          <a:lstStyle/>
+          <a:p>
+            <a:pPr algn="l">
+              <a:spcAft>
+                <a:spcPts val="100"/>
+              </a:spcAft>
+            </a:pPr>
+            <a:r>
+              <a:rPr sz="1200" b="1" lang="en-GB">
+                <a:solidFill>
+                  <a:schemeClr val="tx2"/>
+                </a:solidFill>
+              </a:rPr>
+              <a:t>4 A week's sales have z = −2. That week was …</a:t>
+            </a:r>
+          </a:p>
+          <a:p>
+            <a:pPr algn="l">
+              <a:spcAft>
+                <a:spcPts val="100"/>
+              </a:spcAft>
+            </a:pPr>
+            <a:r>
+              <a:rPr sz="1200" b="0" lang="en-GB">
+                <a:solidFill>
+                  <a:schemeClr val="tx1"/>
+                </a:solidFill>
+              </a:rPr>
+              <a:t>A 2 bars below the mean     B 2 standard deviations below the mean     C 2 % below the mean</a:t>
+            </a:r>
+          </a:p>
+        </p:txBody>
+      </p:sp>
+      <p:sp>
+        <p:nvSpPr>
+          <p:cNvPr id="22" name="Quiz row 5"/>
+          <p:cNvSpPr/>
+          <p:nvPr/>
+        </p:nvSpPr>
+        <p:spPr>
+          <a:xfrm>
+            <a:off x="457200" y="3867912"/>
+            <a:ext cx="8229600" cy="585216"/>
+          </a:xfrm>
+          <a:prstGeom prst="rect">
+            <a:avLst/>
+          </a:prstGeom>
+          <a:solidFill>
+            <a:schemeClr val="bg2"/>
+          </a:solidFill>
+          <a:ln>
+            <a:noFill/>
+          </a:ln>
+          <a:effectLst/>
+        </p:spPr>
+        <p:style>
+          <a:lnRef idx="1">
+            <a:schemeClr val="accent1"/>
+          </a:lnRef>
+          <a:fillRef idx="3">
+            <a:schemeClr val="accent1"/>
+          </a:fillRef>
+          <a:effectRef idx="2">
+            <a:schemeClr val="accent1"/>
+          </a:effectRef>
+          <a:fontRef idx="minor">
+            <a:schemeClr val="lt1"/>
+          </a:fontRef>
+        </p:style>
+        <p:txBody>
+          <a:bodyPr rtlCol="0" anchor="ctr"/>
+          <a:lstStyle/>
+          <a:p/>
+        </p:txBody>
+      </p:sp>
+      <p:sp>
+        <p:nvSpPr>
+          <p:cNvPr id="23" name="Quiz bar 5"/>
+          <p:cNvSpPr/>
+          <p:nvPr/>
+        </p:nvSpPr>
+        <p:spPr>
+          <a:xfrm>
+            <a:off x="457200" y="3867912"/>
+            <a:ext cx="64008" cy="585216"/>
+          </a:xfrm>
+          <a:prstGeom prst="rect">
+            <a:avLst/>
+          </a:prstGeom>
+          <a:solidFill>
+            <a:schemeClr val="accent1"/>
+          </a:solidFill>
+          <a:ln>
+            <a:noFill/>
+          </a:ln>
+          <a:effectLst/>
+        </p:spPr>
+        <p:style>
+          <a:lnRef idx="1">
+            <a:schemeClr val="accent1"/>
+          </a:lnRef>
+          <a:fillRef idx="3">
+            <a:schemeClr val="accent1"/>
+          </a:fillRef>
+          <a:effectRef idx="2">
+            <a:schemeClr val="accent1"/>
+          </a:effectRef>
+          <a:fontRef idx="minor">
+            <a:schemeClr val="lt1"/>
+          </a:fontRef>
+        </p:style>
+        <p:txBody>
+          <a:bodyPr rtlCol="0" anchor="ctr"/>
+          <a:lstStyle/>
+          <a:p/>
+        </p:txBody>
+      </p:sp>
+      <p:sp>
+        <p:nvSpPr>
+          <p:cNvPr id="24" name="Quiz text 5"/>
+          <p:cNvSpPr txBox="1"/>
+          <p:nvPr/>
+        </p:nvSpPr>
+        <p:spPr>
+          <a:xfrm>
+            <a:off x="658368" y="3867912"/>
+            <a:ext cx="7955280" cy="585216"/>
+          </a:xfrm>
+          <a:prstGeom prst="rect">
+            <a:avLst/>
+          </a:prstGeom>
+          <a:noFill/>
+        </p:spPr>
+        <p:txBody>
+          <a:bodyPr wrap="square" lIns="0" rIns="0" tIns="0" bIns="0" anchor="ctr">
+            <a:noAutofit/>
+          </a:bodyPr>
+          <a:lstStyle/>
+          <a:p>
+            <a:pPr algn="l">
+              <a:spcAft>
+                <a:spcPts val="100"/>
+              </a:spcAft>
+            </a:pPr>
+            <a:r>
+              <a:rPr sz="1200" b="1" lang="en-GB">
+                <a:solidFill>
+                  <a:schemeClr val="tx2"/>
+                </a:solidFill>
+              </a:rPr>
+              <a:t>5 Price and bars sold have r = −0.98. What does this mean?</a:t>
+            </a:r>
+          </a:p>
+          <a:p>
+            <a:pPr algn="l">
+              <a:spcAft>
+                <a:spcPts val="100"/>
+              </a:spcAft>
+            </a:pPr>
+            <a:r>
+              <a:rPr sz="1200" b="0" lang="en-GB">
+                <a:solidFill>
+                  <a:schemeClr val="tx1"/>
+                </a:solidFill>
+              </a:rPr>
+              <a:t>A higher prices cause lower sales     B opposite directions, nearly linear     C 0.98 bars fewer per EUR</a:t>
+            </a:r>
+          </a:p>
+        </p:txBody>
+      </p:sp>
+      <p:sp>
+        <p:nvSpPr>
+          <p:cNvPr id="25" name="Quiz how box"/>
+          <p:cNvSpPr/>
+          <p:nvPr/>
+        </p:nvSpPr>
+        <p:spPr>
+          <a:xfrm>
+            <a:off x="457200" y="4572000"/>
+            <a:ext cx="8229600" cy="457200"/>
+          </a:xfrm>
+          <a:prstGeom prst="rect">
             <a:avLst/>
           </a:prstGeom>
           <a:solidFill>
@@ -30470,664 +31184,6 @@
           </a:fontRef>
         </p:style>
         <p:txBody>
-          <a:bodyPr rtlCol="0" anchor="ctr" lIns="0" rIns="0" tIns="0" bIns="0"/>
-          <a:lstStyle/>
-          <a:p>
-            <a:pPr algn="ctr"/>
-            <a:r>
-              <a:rPr sz="1200" b="1" lang="en-GB">
-                <a:solidFill>
-                  <a:schemeClr val="bg1"/>
-                </a:solidFill>
-              </a:rPr>
-              <a:t>1</a:t>
-            </a:r>
-          </a:p>
-        </p:txBody>
-      </p:sp>
-      <p:sp>
-        <p:nvSpPr>
-          <p:cNvPr id="12" name="Takeaways text 1"/>
-          <p:cNvSpPr txBox="1"/>
-          <p:nvPr/>
-        </p:nvSpPr>
-        <p:spPr>
-          <a:xfrm>
-            <a:off x="1051560" y="1234440"/>
-            <a:ext cx="7498080" cy="585216"/>
-          </a:xfrm>
-          <a:prstGeom prst="rect">
-            <a:avLst/>
-          </a:prstGeom>
-          <a:noFill/>
-        </p:spPr>
-        <p:txBody>
-          <a:bodyPr wrap="square" lIns="0" rIns="0" tIns="0" bIns="0" anchor="ctr">
-            <a:noAutofit/>
-          </a:bodyPr>
-          <a:lstStyle/>
-          <a:p>
-            <a:pPr algn="l">
-              <a:spcAft>
-                <a:spcPts val="400"/>
-              </a:spcAft>
-            </a:pPr>
-            <a:r>
-              <a:rPr sz="1200" b="1" lang="en-GB">
-                <a:solidFill>
-                  <a:schemeClr val="tx2"/>
-                </a:solidFill>
-              </a:rPr>
-              <a:t>Scale </a:t>
-            </a:r>
-            <a:r>
-              <a:rPr sz="1200" b="0" lang="en-GB">
-                <a:solidFill>
-                  <a:schemeClr val="tx1"/>
-                </a:solidFill>
-              </a:rPr>
-              <a:t>first: it decides which statistics make sense</a:t>
-            </a:r>
-          </a:p>
-        </p:txBody>
-      </p:sp>
-      <p:sp>
-        <p:nvSpPr>
-          <p:cNvPr id="13" name="Takeaways row 2"/>
-          <p:cNvSpPr/>
-          <p:nvPr/>
-        </p:nvSpPr>
-        <p:spPr>
-          <a:xfrm>
-            <a:off x="457200" y="1901952"/>
-            <a:ext cx="8229600" cy="585216"/>
-          </a:xfrm>
-          <a:prstGeom prst="rect">
-            <a:avLst/>
-          </a:prstGeom>
-          <a:solidFill>
-            <a:schemeClr val="bg2"/>
-          </a:solidFill>
-          <a:ln>
-            <a:noFill/>
-          </a:ln>
-          <a:effectLst/>
-        </p:spPr>
-        <p:style>
-          <a:lnRef idx="1">
-            <a:schemeClr val="accent1"/>
-          </a:lnRef>
-          <a:fillRef idx="3">
-            <a:schemeClr val="accent1"/>
-          </a:fillRef>
-          <a:effectRef idx="2">
-            <a:schemeClr val="accent1"/>
-          </a:effectRef>
-          <a:fontRef idx="minor">
-            <a:schemeClr val="lt1"/>
-          </a:fontRef>
-        </p:style>
-        <p:txBody>
-          <a:bodyPr rtlCol="0" anchor="ctr"/>
-          <a:lstStyle/>
-          <a:p/>
-        </p:txBody>
-      </p:sp>
-      <p:sp>
-        <p:nvSpPr>
-          <p:cNvPr id="14" name="Takeaways number 2"/>
-          <p:cNvSpPr/>
-          <p:nvPr/>
-        </p:nvSpPr>
-        <p:spPr>
-          <a:xfrm>
-            <a:off x="594360" y="2039112"/>
-            <a:ext cx="310896" cy="310896"/>
-          </a:xfrm>
-          <a:prstGeom prst="ellipse">
-            <a:avLst/>
-          </a:prstGeom>
-          <a:solidFill>
-            <a:schemeClr val="tx2"/>
-          </a:solidFill>
-          <a:ln>
-            <a:noFill/>
-          </a:ln>
-          <a:effectLst/>
-        </p:spPr>
-        <p:style>
-          <a:lnRef idx="1">
-            <a:schemeClr val="accent1"/>
-          </a:lnRef>
-          <a:fillRef idx="3">
-            <a:schemeClr val="accent1"/>
-          </a:fillRef>
-          <a:effectRef idx="2">
-            <a:schemeClr val="accent1"/>
-          </a:effectRef>
-          <a:fontRef idx="minor">
-            <a:schemeClr val="lt1"/>
-          </a:fontRef>
-        </p:style>
-        <p:txBody>
-          <a:bodyPr rtlCol="0" anchor="ctr" lIns="0" rIns="0" tIns="0" bIns="0"/>
-          <a:lstStyle/>
-          <a:p>
-            <a:pPr algn="ctr"/>
-            <a:r>
-              <a:rPr sz="1200" b="1" lang="en-GB">
-                <a:solidFill>
-                  <a:schemeClr val="bg1"/>
-                </a:solidFill>
-              </a:rPr>
-              <a:t>2</a:t>
-            </a:r>
-          </a:p>
-        </p:txBody>
-      </p:sp>
-      <p:sp>
-        <p:nvSpPr>
-          <p:cNvPr id="15" name="Takeaways text 2"/>
-          <p:cNvSpPr txBox="1"/>
-          <p:nvPr/>
-        </p:nvSpPr>
-        <p:spPr>
-          <a:xfrm>
-            <a:off x="1051560" y="1901952"/>
-            <a:ext cx="7498080" cy="585216"/>
-          </a:xfrm>
-          <a:prstGeom prst="rect">
-            <a:avLst/>
-          </a:prstGeom>
-          <a:noFill/>
-        </p:spPr>
-        <p:txBody>
-          <a:bodyPr wrap="square" lIns="0" rIns="0" tIns="0" bIns="0" anchor="ctr">
-            <a:noAutofit/>
-          </a:bodyPr>
-          <a:lstStyle/>
-          <a:p>
-            <a:pPr algn="l">
-              <a:spcAft>
-                <a:spcPts val="400"/>
-              </a:spcAft>
-            </a:pPr>
-            <a:r>
-              <a:rPr sz="1200" b="1" lang="en-GB">
-                <a:solidFill>
-                  <a:schemeClr val="tx2"/>
-                </a:solidFill>
-              </a:rPr>
-              <a:t>Mean and median: </a:t>
-            </a:r>
-            <a:r>
-              <a:rPr sz="1200" b="0" lang="en-GB">
-                <a:solidFill>
-                  <a:schemeClr val="tx1"/>
-                </a:solidFill>
-              </a:rPr>
-              <a:t>the median resists outliers; totals need the mean</a:t>
-            </a:r>
-          </a:p>
-        </p:txBody>
-      </p:sp>
-      <p:sp>
-        <p:nvSpPr>
-          <p:cNvPr id="16" name="Takeaways row 3"/>
-          <p:cNvSpPr/>
-          <p:nvPr/>
-        </p:nvSpPr>
-        <p:spPr>
-          <a:xfrm>
-            <a:off x="457200" y="2569464"/>
-            <a:ext cx="8229600" cy="585216"/>
-          </a:xfrm>
-          <a:prstGeom prst="rect">
-            <a:avLst/>
-          </a:prstGeom>
-          <a:solidFill>
-            <a:schemeClr val="bg2"/>
-          </a:solidFill>
-          <a:ln>
-            <a:noFill/>
-          </a:ln>
-          <a:effectLst/>
-        </p:spPr>
-        <p:style>
-          <a:lnRef idx="1">
-            <a:schemeClr val="accent1"/>
-          </a:lnRef>
-          <a:fillRef idx="3">
-            <a:schemeClr val="accent1"/>
-          </a:fillRef>
-          <a:effectRef idx="2">
-            <a:schemeClr val="accent1"/>
-          </a:effectRef>
-          <a:fontRef idx="minor">
-            <a:schemeClr val="lt1"/>
-          </a:fontRef>
-        </p:style>
-        <p:txBody>
-          <a:bodyPr rtlCol="0" anchor="ctr"/>
-          <a:lstStyle/>
-          <a:p/>
-        </p:txBody>
-      </p:sp>
-      <p:sp>
-        <p:nvSpPr>
-          <p:cNvPr id="17" name="Takeaways number 3"/>
-          <p:cNvSpPr/>
-          <p:nvPr/>
-        </p:nvSpPr>
-        <p:spPr>
-          <a:xfrm>
-            <a:off x="594360" y="2706624"/>
-            <a:ext cx="310896" cy="310896"/>
-          </a:xfrm>
-          <a:prstGeom prst="ellipse">
-            <a:avLst/>
-          </a:prstGeom>
-          <a:solidFill>
-            <a:schemeClr val="tx2"/>
-          </a:solidFill>
-          <a:ln>
-            <a:noFill/>
-          </a:ln>
-          <a:effectLst/>
-        </p:spPr>
-        <p:style>
-          <a:lnRef idx="1">
-            <a:schemeClr val="accent1"/>
-          </a:lnRef>
-          <a:fillRef idx="3">
-            <a:schemeClr val="accent1"/>
-          </a:fillRef>
-          <a:effectRef idx="2">
-            <a:schemeClr val="accent1"/>
-          </a:effectRef>
-          <a:fontRef idx="minor">
-            <a:schemeClr val="lt1"/>
-          </a:fontRef>
-        </p:style>
-        <p:txBody>
-          <a:bodyPr rtlCol="0" anchor="ctr" lIns="0" rIns="0" tIns="0" bIns="0"/>
-          <a:lstStyle/>
-          <a:p>
-            <a:pPr algn="ctr"/>
-            <a:r>
-              <a:rPr sz="1200" b="1" lang="en-GB">
-                <a:solidFill>
-                  <a:schemeClr val="bg1"/>
-                </a:solidFill>
-              </a:rPr>
-              <a:t>3</a:t>
-            </a:r>
-          </a:p>
-        </p:txBody>
-      </p:sp>
-      <p:sp>
-        <p:nvSpPr>
-          <p:cNvPr id="18" name="Takeaways text 3"/>
-          <p:cNvSpPr txBox="1"/>
-          <p:nvPr/>
-        </p:nvSpPr>
-        <p:spPr>
-          <a:xfrm>
-            <a:off x="1051560" y="2569464"/>
-            <a:ext cx="7498080" cy="585216"/>
-          </a:xfrm>
-          <a:prstGeom prst="rect">
-            <a:avLst/>
-          </a:prstGeom>
-          <a:noFill/>
-        </p:spPr>
-        <p:txBody>
-          <a:bodyPr wrap="square" lIns="0" rIns="0" tIns="0" bIns="0" anchor="ctr">
-            <a:noAutofit/>
-          </a:bodyPr>
-          <a:lstStyle/>
-          <a:p>
-            <a:pPr algn="l">
-              <a:spcAft>
-                <a:spcPts val="400"/>
-              </a:spcAft>
-            </a:pPr>
-            <a:r>
-              <a:rPr sz="1200" b="1" lang="en-GB">
-                <a:solidFill>
-                  <a:schemeClr val="tx2"/>
-                </a:solidFill>
-              </a:rPr>
-              <a:t>sd </a:t>
-            </a:r>
-            <a:r>
-              <a:rPr sz="1200" b="0" lang="en-GB">
-                <a:solidFill>
-                  <a:schemeClr val="tx1"/>
-                </a:solidFill>
-              </a:rPr>
-              <a:t>describes the data; SE = sd / √n describes the precision of the mean</a:t>
-            </a:r>
-          </a:p>
-        </p:txBody>
-      </p:sp>
-      <p:sp>
-        <p:nvSpPr>
-          <p:cNvPr id="19" name="Takeaways row 4"/>
-          <p:cNvSpPr/>
-          <p:nvPr/>
-        </p:nvSpPr>
-        <p:spPr>
-          <a:xfrm>
-            <a:off x="457200" y="3236976"/>
-            <a:ext cx="8229600" cy="585216"/>
-          </a:xfrm>
-          <a:prstGeom prst="rect">
-            <a:avLst/>
-          </a:prstGeom>
-          <a:solidFill>
-            <a:schemeClr val="bg2"/>
-          </a:solidFill>
-          <a:ln>
-            <a:noFill/>
-          </a:ln>
-          <a:effectLst/>
-        </p:spPr>
-        <p:style>
-          <a:lnRef idx="1">
-            <a:schemeClr val="accent1"/>
-          </a:lnRef>
-          <a:fillRef idx="3">
-            <a:schemeClr val="accent1"/>
-          </a:fillRef>
-          <a:effectRef idx="2">
-            <a:schemeClr val="accent1"/>
-          </a:effectRef>
-          <a:fontRef idx="minor">
-            <a:schemeClr val="lt1"/>
-          </a:fontRef>
-        </p:style>
-        <p:txBody>
-          <a:bodyPr rtlCol="0" anchor="ctr"/>
-          <a:lstStyle/>
-          <a:p/>
-        </p:txBody>
-      </p:sp>
-      <p:sp>
-        <p:nvSpPr>
-          <p:cNvPr id="20" name="Takeaways number 4"/>
-          <p:cNvSpPr/>
-          <p:nvPr/>
-        </p:nvSpPr>
-        <p:spPr>
-          <a:xfrm>
-            <a:off x="594360" y="3374136"/>
-            <a:ext cx="310896" cy="310896"/>
-          </a:xfrm>
-          <a:prstGeom prst="ellipse">
-            <a:avLst/>
-          </a:prstGeom>
-          <a:solidFill>
-            <a:schemeClr val="tx2"/>
-          </a:solidFill>
-          <a:ln>
-            <a:noFill/>
-          </a:ln>
-          <a:effectLst/>
-        </p:spPr>
-        <p:style>
-          <a:lnRef idx="1">
-            <a:schemeClr val="accent1"/>
-          </a:lnRef>
-          <a:fillRef idx="3">
-            <a:schemeClr val="accent1"/>
-          </a:fillRef>
-          <a:effectRef idx="2">
-            <a:schemeClr val="accent1"/>
-          </a:effectRef>
-          <a:fontRef idx="minor">
-            <a:schemeClr val="lt1"/>
-          </a:fontRef>
-        </p:style>
-        <p:txBody>
-          <a:bodyPr rtlCol="0" anchor="ctr" lIns="0" rIns="0" tIns="0" bIns="0"/>
-          <a:lstStyle/>
-          <a:p>
-            <a:pPr algn="ctr"/>
-            <a:r>
-              <a:rPr sz="1200" b="1" lang="en-GB">
-                <a:solidFill>
-                  <a:schemeClr val="bg1"/>
-                </a:solidFill>
-              </a:rPr>
-              <a:t>4</a:t>
-            </a:r>
-          </a:p>
-        </p:txBody>
-      </p:sp>
-      <p:sp>
-        <p:nvSpPr>
-          <p:cNvPr id="21" name="Takeaways text 4"/>
-          <p:cNvSpPr txBox="1"/>
-          <p:nvPr/>
-        </p:nvSpPr>
-        <p:spPr>
-          <a:xfrm>
-            <a:off x="1051560" y="3236976"/>
-            <a:ext cx="7498080" cy="585216"/>
-          </a:xfrm>
-          <a:prstGeom prst="rect">
-            <a:avLst/>
-          </a:prstGeom>
-          <a:noFill/>
-        </p:spPr>
-        <p:txBody>
-          <a:bodyPr wrap="square" lIns="0" rIns="0" tIns="0" bIns="0" anchor="ctr">
-            <a:noAutofit/>
-          </a:bodyPr>
-          <a:lstStyle/>
-          <a:p>
-            <a:pPr algn="l">
-              <a:spcAft>
-                <a:spcPts val="400"/>
-              </a:spcAft>
-            </a:pPr>
-            <a:r>
-              <a:rPr sz="1200" b="1" lang="en-GB">
-                <a:solidFill>
-                  <a:schemeClr val="tx2"/>
-                </a:solidFill>
-              </a:rPr>
-              <a:t>z = (x − x̄) / s </a:t>
-            </a:r>
-            <a:r>
-              <a:rPr sz="1200" b="0" lang="en-GB">
-                <a:solidFill>
-                  <a:schemeClr val="tx1"/>
-                </a:solidFill>
-              </a:rPr>
-              <a:t>makes values comparable; 95 % of a normal lies within ±1.96 sd</a:t>
-            </a:r>
-          </a:p>
-        </p:txBody>
-      </p:sp>
-      <p:sp>
-        <p:nvSpPr>
-          <p:cNvPr id="22" name="Takeaways row 5"/>
-          <p:cNvSpPr/>
-          <p:nvPr/>
-        </p:nvSpPr>
-        <p:spPr>
-          <a:xfrm>
-            <a:off x="457200" y="3904488"/>
-            <a:ext cx="8229600" cy="585216"/>
-          </a:xfrm>
-          <a:prstGeom prst="rect">
-            <a:avLst/>
-          </a:prstGeom>
-          <a:solidFill>
-            <a:schemeClr val="bg2"/>
-          </a:solidFill>
-          <a:ln>
-            <a:noFill/>
-          </a:ln>
-          <a:effectLst/>
-        </p:spPr>
-        <p:style>
-          <a:lnRef idx="1">
-            <a:schemeClr val="accent1"/>
-          </a:lnRef>
-          <a:fillRef idx="3">
-            <a:schemeClr val="accent1"/>
-          </a:fillRef>
-          <a:effectRef idx="2">
-            <a:schemeClr val="accent1"/>
-          </a:effectRef>
-          <a:fontRef idx="minor">
-            <a:schemeClr val="lt1"/>
-          </a:fontRef>
-        </p:style>
-        <p:txBody>
-          <a:bodyPr rtlCol="0" anchor="ctr"/>
-          <a:lstStyle/>
-          <a:p/>
-        </p:txBody>
-      </p:sp>
-      <p:sp>
-        <p:nvSpPr>
-          <p:cNvPr id="23" name="Takeaways number 5"/>
-          <p:cNvSpPr/>
-          <p:nvPr/>
-        </p:nvSpPr>
-        <p:spPr>
-          <a:xfrm>
-            <a:off x="594360" y="4041648"/>
-            <a:ext cx="310896" cy="310896"/>
-          </a:xfrm>
-          <a:prstGeom prst="ellipse">
-            <a:avLst/>
-          </a:prstGeom>
-          <a:solidFill>
-            <a:schemeClr val="tx2"/>
-          </a:solidFill>
-          <a:ln>
-            <a:noFill/>
-          </a:ln>
-          <a:effectLst/>
-        </p:spPr>
-        <p:style>
-          <a:lnRef idx="1">
-            <a:schemeClr val="accent1"/>
-          </a:lnRef>
-          <a:fillRef idx="3">
-            <a:schemeClr val="accent1"/>
-          </a:fillRef>
-          <a:effectRef idx="2">
-            <a:schemeClr val="accent1"/>
-          </a:effectRef>
-          <a:fontRef idx="minor">
-            <a:schemeClr val="lt1"/>
-          </a:fontRef>
-        </p:style>
-        <p:txBody>
-          <a:bodyPr rtlCol="0" anchor="ctr" lIns="0" rIns="0" tIns="0" bIns="0"/>
-          <a:lstStyle/>
-          <a:p>
-            <a:pPr algn="ctr"/>
-            <a:r>
-              <a:rPr sz="1200" b="1" lang="en-GB">
-                <a:solidFill>
-                  <a:schemeClr val="bg1"/>
-                </a:solidFill>
-              </a:rPr>
-              <a:t>5</a:t>
-            </a:r>
-          </a:p>
-        </p:txBody>
-      </p:sp>
-      <p:sp>
-        <p:nvSpPr>
-          <p:cNvPr id="24" name="Takeaways text 5"/>
-          <p:cNvSpPr txBox="1"/>
-          <p:nvPr/>
-        </p:nvSpPr>
-        <p:spPr>
-          <a:xfrm>
-            <a:off x="1051560" y="3904488"/>
-            <a:ext cx="7498080" cy="585216"/>
-          </a:xfrm>
-          <a:prstGeom prst="rect">
-            <a:avLst/>
-          </a:prstGeom>
-          <a:noFill/>
-        </p:spPr>
-        <p:txBody>
-          <a:bodyPr wrap="square" lIns="0" rIns="0" tIns="0" bIns="0" anchor="ctr">
-            <a:noAutofit/>
-          </a:bodyPr>
-          <a:lstStyle/>
-          <a:p>
-            <a:pPr algn="l">
-              <a:spcAft>
-                <a:spcPts val="400"/>
-              </a:spcAft>
-            </a:pPr>
-            <a:r>
-              <a:rPr sz="1200" b="1" lang="en-GB">
-                <a:solidFill>
-                  <a:schemeClr val="tx2"/>
-                </a:solidFill>
-              </a:rPr>
-              <a:t>Covariance </a:t>
-            </a:r>
-            <a:r>
-              <a:rPr sz="1200" b="0" lang="en-GB">
-                <a:solidFill>
-                  <a:schemeClr val="tx1"/>
-                </a:solidFill>
-              </a:rPr>
-              <a:t>gives the direction, correlation the strength (−1 to +1), regression the size</a:t>
-            </a:r>
-          </a:p>
-        </p:txBody>
-      </p:sp>
-      <p:sp>
-        <p:nvSpPr>
-          <p:cNvPr id="25" name="Take next box"/>
-          <p:cNvSpPr/>
-          <p:nvPr/>
-        </p:nvSpPr>
-        <p:spPr>
-          <a:xfrm>
-            <a:off x="457200" y="4572000"/>
-            <a:ext cx="8229600" cy="457200"/>
-          </a:xfrm>
-          <a:prstGeom prst="rect">
-            <a:avLst/>
-          </a:prstGeom>
-          <a:solidFill>
-            <a:schemeClr val="tx2"/>
-          </a:solidFill>
-          <a:ln>
-            <a:noFill/>
-          </a:ln>
-          <a:effectLst/>
-        </p:spPr>
-        <p:style>
-          <a:lnRef idx="1">
-            <a:schemeClr val="accent1"/>
-          </a:lnRef>
-          <a:fillRef idx="3">
-            <a:schemeClr val="accent1"/>
-          </a:fillRef>
-          <a:effectRef idx="2">
-            <a:schemeClr val="accent1"/>
-          </a:effectRef>
-          <a:fontRef idx="minor">
-            <a:schemeClr val="lt1"/>
-          </a:fontRef>
-        </p:style>
-        <p:txBody>
           <a:bodyPr rtlCol="0" anchor="ctr"/>
           <a:lstStyle/>
           <a:p/>
@@ -31135,7 +31191,7 @@
       </p:sp>
       <p:pic>
         <p:nvPicPr>
-          <p:cNvPr id="26" name="Icon Take next" descr=""/>
+          <p:cNvPr id="26" name="Icon Quiz how" descr=""/>
           <p:cNvPicPr>
             <a:picLocks noChangeAspect="1"/>
           </p:cNvPicPr>
@@ -31159,7 +31215,7 @@
       </p:pic>
       <p:sp>
         <p:nvSpPr>
-          <p:cNvPr id="27" name="Take next text"/>
+          <p:cNvPr id="27" name="Quiz how text"/>
           <p:cNvSpPr txBox="1"/>
           <p:nvPr/>
         </p:nvSpPr>
@@ -31190,7 +31246,7 @@
                   <a:schemeClr val="bg1"/>
                 </a:solidFill>
               </a:rPr>
-              <a:t>Next: </a:t>
+              <a:t>3 minutes alone, </a:t>
             </a:r>
             <a:r>
               <a:rPr sz="1200" b="0" lang="en-GB">
@@ -31198,7 +31254,7 @@
                   <a:schemeClr val="bg1"/>
                 </a:solidFill>
               </a:rPr>
-              <a:t>linear regression on real chocolate data.</a:t>
+              <a:t>then compare with your neighbour. Same format as the online quiz and the exam.</a:t>
             </a:r>
           </a:p>
         </p:txBody>
@@ -31238,7 +31294,7 @@
           <a:p>
             <a:r>
               <a:rPr sz="1600" lang="en-GB"/>
-              <a:t>References</a:t>
+              <a:t>Key takeaways</a:t>
             </a:r>
           </a:p>
         </p:txBody>
@@ -31294,20 +31350,20 @@
       </p:sp>
       <p:sp>
         <p:nvSpPr>
-          <p:cNvPr id="10" name="Ref 1 header"/>
+          <p:cNvPr id="10" name="Takeaways row 1"/>
           <p:cNvSpPr/>
           <p:nvPr/>
         </p:nvSpPr>
         <p:spPr>
           <a:xfrm>
             <a:off x="457200" y="1234440"/>
-            <a:ext cx="4046220" cy="411480"/>
+            <a:ext cx="8229600" cy="585216"/>
           </a:xfrm>
           <a:prstGeom prst="rect">
             <a:avLst/>
           </a:prstGeom>
           <a:solidFill>
-            <a:schemeClr val="accent1"/>
+            <a:schemeClr val="bg2"/>
           </a:solidFill>
           <a:ln>
             <a:noFill/>
@@ -31336,14 +31392,66 @@
       </p:sp>
       <p:sp>
         <p:nvSpPr>
-          <p:cNvPr id="11" name="Ref 1 heading"/>
+          <p:cNvPr id="11" name="Takeaways number 1"/>
+          <p:cNvSpPr/>
+          <p:nvPr/>
+        </p:nvSpPr>
+        <p:spPr>
+          <a:xfrm>
+            <a:off x="594360" y="1371600"/>
+            <a:ext cx="310896" cy="310896"/>
+          </a:xfrm>
+          <a:prstGeom prst="ellipse">
+            <a:avLst/>
+          </a:prstGeom>
+          <a:solidFill>
+            <a:schemeClr val="tx2"/>
+          </a:solidFill>
+          <a:ln>
+            <a:noFill/>
+          </a:ln>
+          <a:effectLst/>
+        </p:spPr>
+        <p:style>
+          <a:lnRef idx="1">
+            <a:schemeClr val="accent1"/>
+          </a:lnRef>
+          <a:fillRef idx="3">
+            <a:schemeClr val="accent1"/>
+          </a:fillRef>
+          <a:effectRef idx="2">
+            <a:schemeClr val="accent1"/>
+          </a:effectRef>
+          <a:fontRef idx="minor">
+            <a:schemeClr val="lt1"/>
+          </a:fontRef>
+        </p:style>
+        <p:txBody>
+          <a:bodyPr rtlCol="0" anchor="ctr" lIns="0" rIns="0" tIns="0" bIns="0"/>
+          <a:lstStyle/>
+          <a:p>
+            <a:pPr algn="ctr"/>
+            <a:r>
+              <a:rPr sz="1200" b="1" lang="en-GB">
+                <a:solidFill>
+                  <a:schemeClr val="bg1"/>
+                </a:solidFill>
+              </a:rPr>
+              <a:t>1</a:t>
+            </a:r>
+          </a:p>
+        </p:txBody>
+      </p:sp>
+      <p:sp>
+        <p:nvSpPr>
+          <p:cNvPr id="12" name="Takeaways text 1"/>
           <p:cNvSpPr txBox="1"/>
           <p:nvPr/>
         </p:nvSpPr>
         <p:spPr>
           <a:xfrm>
-            <a:off x="594360" y="1234440"/>
-            <a:ext cx="3360420" cy="411480"/>
+            <a:off x="1051560" y="1234440"/>
+            <a:ext cx="7498080" cy="585216"/>
           </a:xfrm>
           <a:prstGeom prst="rect">
             <a:avLst/>
@@ -31362,20 +31470,629 @@
               </a:spcAft>
             </a:pPr>
             <a:r>
-              <a:rPr sz="1500" b="1" lang="en-GB">
+              <a:rPr sz="1200" b="1" lang="en-GB">
+                <a:solidFill>
+                  <a:schemeClr val="tx2"/>
+                </a:solidFill>
+              </a:rPr>
+              <a:t>Scale </a:t>
+            </a:r>
+            <a:r>
+              <a:rPr sz="1200" b="0" lang="en-GB">
+                <a:solidFill>
+                  <a:schemeClr val="tx1"/>
+                </a:solidFill>
+              </a:rPr>
+              <a:t>first: it decides which statistics make sense</a:t>
+            </a:r>
+          </a:p>
+        </p:txBody>
+      </p:sp>
+      <p:sp>
+        <p:nvSpPr>
+          <p:cNvPr id="13" name="Takeaways row 2"/>
+          <p:cNvSpPr/>
+          <p:nvPr/>
+        </p:nvSpPr>
+        <p:spPr>
+          <a:xfrm>
+            <a:off x="457200" y="1901952"/>
+            <a:ext cx="8229600" cy="585216"/>
+          </a:xfrm>
+          <a:prstGeom prst="rect">
+            <a:avLst/>
+          </a:prstGeom>
+          <a:solidFill>
+            <a:schemeClr val="bg2"/>
+          </a:solidFill>
+          <a:ln>
+            <a:noFill/>
+          </a:ln>
+          <a:effectLst/>
+        </p:spPr>
+        <p:style>
+          <a:lnRef idx="1">
+            <a:schemeClr val="accent1"/>
+          </a:lnRef>
+          <a:fillRef idx="3">
+            <a:schemeClr val="accent1"/>
+          </a:fillRef>
+          <a:effectRef idx="2">
+            <a:schemeClr val="accent1"/>
+          </a:effectRef>
+          <a:fontRef idx="minor">
+            <a:schemeClr val="lt1"/>
+          </a:fontRef>
+        </p:style>
+        <p:txBody>
+          <a:bodyPr rtlCol="0" anchor="ctr"/>
+          <a:lstStyle/>
+          <a:p/>
+        </p:txBody>
+      </p:sp>
+      <p:sp>
+        <p:nvSpPr>
+          <p:cNvPr id="14" name="Takeaways number 2"/>
+          <p:cNvSpPr/>
+          <p:nvPr/>
+        </p:nvSpPr>
+        <p:spPr>
+          <a:xfrm>
+            <a:off x="594360" y="2039112"/>
+            <a:ext cx="310896" cy="310896"/>
+          </a:xfrm>
+          <a:prstGeom prst="ellipse">
+            <a:avLst/>
+          </a:prstGeom>
+          <a:solidFill>
+            <a:schemeClr val="tx2"/>
+          </a:solidFill>
+          <a:ln>
+            <a:noFill/>
+          </a:ln>
+          <a:effectLst/>
+        </p:spPr>
+        <p:style>
+          <a:lnRef idx="1">
+            <a:schemeClr val="accent1"/>
+          </a:lnRef>
+          <a:fillRef idx="3">
+            <a:schemeClr val="accent1"/>
+          </a:fillRef>
+          <a:effectRef idx="2">
+            <a:schemeClr val="accent1"/>
+          </a:effectRef>
+          <a:fontRef idx="minor">
+            <a:schemeClr val="lt1"/>
+          </a:fontRef>
+        </p:style>
+        <p:txBody>
+          <a:bodyPr rtlCol="0" anchor="ctr" lIns="0" rIns="0" tIns="0" bIns="0"/>
+          <a:lstStyle/>
+          <a:p>
+            <a:pPr algn="ctr"/>
+            <a:r>
+              <a:rPr sz="1200" b="1" lang="en-GB">
                 <a:solidFill>
                   <a:schemeClr val="bg1"/>
                 </a:solidFill>
-                <a:latin typeface="+mj-lt"/>
-              </a:rPr>
-              <a:t>Books and readings</a:t>
-            </a:r>
-          </a:p>
+              </a:rPr>
+              <a:t>2</a:t>
+            </a:r>
+          </a:p>
+        </p:txBody>
+      </p:sp>
+      <p:sp>
+        <p:nvSpPr>
+          <p:cNvPr id="15" name="Takeaways text 2"/>
+          <p:cNvSpPr txBox="1"/>
+          <p:nvPr/>
+        </p:nvSpPr>
+        <p:spPr>
+          <a:xfrm>
+            <a:off x="1051560" y="1901952"/>
+            <a:ext cx="7498080" cy="585216"/>
+          </a:xfrm>
+          <a:prstGeom prst="rect">
+            <a:avLst/>
+          </a:prstGeom>
+          <a:noFill/>
+        </p:spPr>
+        <p:txBody>
+          <a:bodyPr wrap="square" lIns="0" rIns="0" tIns="0" bIns="0" anchor="ctr">
+            <a:noAutofit/>
+          </a:bodyPr>
+          <a:lstStyle/>
+          <a:p>
+            <a:pPr algn="l">
+              <a:spcAft>
+                <a:spcPts val="400"/>
+              </a:spcAft>
+            </a:pPr>
+            <a:r>
+              <a:rPr sz="1200" b="1" lang="en-GB">
+                <a:solidFill>
+                  <a:schemeClr val="tx2"/>
+                </a:solidFill>
+              </a:rPr>
+              <a:t>Mean and median: </a:t>
+            </a:r>
+            <a:r>
+              <a:rPr sz="1200" b="0" lang="en-GB">
+                <a:solidFill>
+                  <a:schemeClr val="tx1"/>
+                </a:solidFill>
+              </a:rPr>
+              <a:t>the median resists outliers; totals need the mean</a:t>
+            </a:r>
+          </a:p>
+        </p:txBody>
+      </p:sp>
+      <p:sp>
+        <p:nvSpPr>
+          <p:cNvPr id="16" name="Takeaways row 3"/>
+          <p:cNvSpPr/>
+          <p:nvPr/>
+        </p:nvSpPr>
+        <p:spPr>
+          <a:xfrm>
+            <a:off x="457200" y="2569464"/>
+            <a:ext cx="8229600" cy="585216"/>
+          </a:xfrm>
+          <a:prstGeom prst="rect">
+            <a:avLst/>
+          </a:prstGeom>
+          <a:solidFill>
+            <a:schemeClr val="bg2"/>
+          </a:solidFill>
+          <a:ln>
+            <a:noFill/>
+          </a:ln>
+          <a:effectLst/>
+        </p:spPr>
+        <p:style>
+          <a:lnRef idx="1">
+            <a:schemeClr val="accent1"/>
+          </a:lnRef>
+          <a:fillRef idx="3">
+            <a:schemeClr val="accent1"/>
+          </a:fillRef>
+          <a:effectRef idx="2">
+            <a:schemeClr val="accent1"/>
+          </a:effectRef>
+          <a:fontRef idx="minor">
+            <a:schemeClr val="lt1"/>
+          </a:fontRef>
+        </p:style>
+        <p:txBody>
+          <a:bodyPr rtlCol="0" anchor="ctr"/>
+          <a:lstStyle/>
+          <a:p/>
+        </p:txBody>
+      </p:sp>
+      <p:sp>
+        <p:nvSpPr>
+          <p:cNvPr id="17" name="Takeaways number 3"/>
+          <p:cNvSpPr/>
+          <p:nvPr/>
+        </p:nvSpPr>
+        <p:spPr>
+          <a:xfrm>
+            <a:off x="594360" y="2706624"/>
+            <a:ext cx="310896" cy="310896"/>
+          </a:xfrm>
+          <a:prstGeom prst="ellipse">
+            <a:avLst/>
+          </a:prstGeom>
+          <a:solidFill>
+            <a:schemeClr val="tx2"/>
+          </a:solidFill>
+          <a:ln>
+            <a:noFill/>
+          </a:ln>
+          <a:effectLst/>
+        </p:spPr>
+        <p:style>
+          <a:lnRef idx="1">
+            <a:schemeClr val="accent1"/>
+          </a:lnRef>
+          <a:fillRef idx="3">
+            <a:schemeClr val="accent1"/>
+          </a:fillRef>
+          <a:effectRef idx="2">
+            <a:schemeClr val="accent1"/>
+          </a:effectRef>
+          <a:fontRef idx="minor">
+            <a:schemeClr val="lt1"/>
+          </a:fontRef>
+        </p:style>
+        <p:txBody>
+          <a:bodyPr rtlCol="0" anchor="ctr" lIns="0" rIns="0" tIns="0" bIns="0"/>
+          <a:lstStyle/>
+          <a:p>
+            <a:pPr algn="ctr"/>
+            <a:r>
+              <a:rPr sz="1200" b="1" lang="en-GB">
+                <a:solidFill>
+                  <a:schemeClr val="bg1"/>
+                </a:solidFill>
+              </a:rPr>
+              <a:t>3</a:t>
+            </a:r>
+          </a:p>
+        </p:txBody>
+      </p:sp>
+      <p:sp>
+        <p:nvSpPr>
+          <p:cNvPr id="18" name="Takeaways text 3"/>
+          <p:cNvSpPr txBox="1"/>
+          <p:nvPr/>
+        </p:nvSpPr>
+        <p:spPr>
+          <a:xfrm>
+            <a:off x="1051560" y="2569464"/>
+            <a:ext cx="7498080" cy="585216"/>
+          </a:xfrm>
+          <a:prstGeom prst="rect">
+            <a:avLst/>
+          </a:prstGeom>
+          <a:noFill/>
+        </p:spPr>
+        <p:txBody>
+          <a:bodyPr wrap="square" lIns="0" rIns="0" tIns="0" bIns="0" anchor="ctr">
+            <a:noAutofit/>
+          </a:bodyPr>
+          <a:lstStyle/>
+          <a:p>
+            <a:pPr algn="l">
+              <a:spcAft>
+                <a:spcPts val="400"/>
+              </a:spcAft>
+            </a:pPr>
+            <a:r>
+              <a:rPr sz="1200" b="1" lang="en-GB">
+                <a:solidFill>
+                  <a:schemeClr val="tx2"/>
+                </a:solidFill>
+              </a:rPr>
+              <a:t>sd </a:t>
+            </a:r>
+            <a:r>
+              <a:rPr sz="1200" b="0" lang="en-GB">
+                <a:solidFill>
+                  <a:schemeClr val="tx1"/>
+                </a:solidFill>
+              </a:rPr>
+              <a:t>describes the data; SE = sd / √n describes the precision of the mean</a:t>
+            </a:r>
+          </a:p>
+        </p:txBody>
+      </p:sp>
+      <p:sp>
+        <p:nvSpPr>
+          <p:cNvPr id="19" name="Takeaways row 4"/>
+          <p:cNvSpPr/>
+          <p:nvPr/>
+        </p:nvSpPr>
+        <p:spPr>
+          <a:xfrm>
+            <a:off x="457200" y="3236976"/>
+            <a:ext cx="8229600" cy="585216"/>
+          </a:xfrm>
+          <a:prstGeom prst="rect">
+            <a:avLst/>
+          </a:prstGeom>
+          <a:solidFill>
+            <a:schemeClr val="bg2"/>
+          </a:solidFill>
+          <a:ln>
+            <a:noFill/>
+          </a:ln>
+          <a:effectLst/>
+        </p:spPr>
+        <p:style>
+          <a:lnRef idx="1">
+            <a:schemeClr val="accent1"/>
+          </a:lnRef>
+          <a:fillRef idx="3">
+            <a:schemeClr val="accent1"/>
+          </a:fillRef>
+          <a:effectRef idx="2">
+            <a:schemeClr val="accent1"/>
+          </a:effectRef>
+          <a:fontRef idx="minor">
+            <a:schemeClr val="lt1"/>
+          </a:fontRef>
+        </p:style>
+        <p:txBody>
+          <a:bodyPr rtlCol="0" anchor="ctr"/>
+          <a:lstStyle/>
+          <a:p/>
+        </p:txBody>
+      </p:sp>
+      <p:sp>
+        <p:nvSpPr>
+          <p:cNvPr id="20" name="Takeaways number 4"/>
+          <p:cNvSpPr/>
+          <p:nvPr/>
+        </p:nvSpPr>
+        <p:spPr>
+          <a:xfrm>
+            <a:off x="594360" y="3374136"/>
+            <a:ext cx="310896" cy="310896"/>
+          </a:xfrm>
+          <a:prstGeom prst="ellipse">
+            <a:avLst/>
+          </a:prstGeom>
+          <a:solidFill>
+            <a:schemeClr val="tx2"/>
+          </a:solidFill>
+          <a:ln>
+            <a:noFill/>
+          </a:ln>
+          <a:effectLst/>
+        </p:spPr>
+        <p:style>
+          <a:lnRef idx="1">
+            <a:schemeClr val="accent1"/>
+          </a:lnRef>
+          <a:fillRef idx="3">
+            <a:schemeClr val="accent1"/>
+          </a:fillRef>
+          <a:effectRef idx="2">
+            <a:schemeClr val="accent1"/>
+          </a:effectRef>
+          <a:fontRef idx="minor">
+            <a:schemeClr val="lt1"/>
+          </a:fontRef>
+        </p:style>
+        <p:txBody>
+          <a:bodyPr rtlCol="0" anchor="ctr" lIns="0" rIns="0" tIns="0" bIns="0"/>
+          <a:lstStyle/>
+          <a:p>
+            <a:pPr algn="ctr"/>
+            <a:r>
+              <a:rPr sz="1200" b="1" lang="en-GB">
+                <a:solidFill>
+                  <a:schemeClr val="bg1"/>
+                </a:solidFill>
+              </a:rPr>
+              <a:t>4</a:t>
+            </a:r>
+          </a:p>
+        </p:txBody>
+      </p:sp>
+      <p:sp>
+        <p:nvSpPr>
+          <p:cNvPr id="21" name="Takeaways text 4"/>
+          <p:cNvSpPr txBox="1"/>
+          <p:nvPr/>
+        </p:nvSpPr>
+        <p:spPr>
+          <a:xfrm>
+            <a:off x="1051560" y="3236976"/>
+            <a:ext cx="7498080" cy="585216"/>
+          </a:xfrm>
+          <a:prstGeom prst="rect">
+            <a:avLst/>
+          </a:prstGeom>
+          <a:noFill/>
+        </p:spPr>
+        <p:txBody>
+          <a:bodyPr wrap="square" lIns="0" rIns="0" tIns="0" bIns="0" anchor="ctr">
+            <a:noAutofit/>
+          </a:bodyPr>
+          <a:lstStyle/>
+          <a:p>
+            <a:pPr algn="l">
+              <a:spcAft>
+                <a:spcPts val="400"/>
+              </a:spcAft>
+            </a:pPr>
+            <a:r>
+              <a:rPr sz="1200" b="1" lang="en-GB">
+                <a:solidFill>
+                  <a:schemeClr val="tx2"/>
+                </a:solidFill>
+              </a:rPr>
+              <a:t>z = (x − x̄) / s </a:t>
+            </a:r>
+            <a:r>
+              <a:rPr sz="1200" b="0" lang="en-GB">
+                <a:solidFill>
+                  <a:schemeClr val="tx1"/>
+                </a:solidFill>
+              </a:rPr>
+              <a:t>makes values comparable; 95 % of a normal lies within ±1.96 sd</a:t>
+            </a:r>
+          </a:p>
+        </p:txBody>
+      </p:sp>
+      <p:sp>
+        <p:nvSpPr>
+          <p:cNvPr id="22" name="Takeaways row 5"/>
+          <p:cNvSpPr/>
+          <p:nvPr/>
+        </p:nvSpPr>
+        <p:spPr>
+          <a:xfrm>
+            <a:off x="457200" y="3904488"/>
+            <a:ext cx="8229600" cy="585216"/>
+          </a:xfrm>
+          <a:prstGeom prst="rect">
+            <a:avLst/>
+          </a:prstGeom>
+          <a:solidFill>
+            <a:schemeClr val="bg2"/>
+          </a:solidFill>
+          <a:ln>
+            <a:noFill/>
+          </a:ln>
+          <a:effectLst/>
+        </p:spPr>
+        <p:style>
+          <a:lnRef idx="1">
+            <a:schemeClr val="accent1"/>
+          </a:lnRef>
+          <a:fillRef idx="3">
+            <a:schemeClr val="accent1"/>
+          </a:fillRef>
+          <a:effectRef idx="2">
+            <a:schemeClr val="accent1"/>
+          </a:effectRef>
+          <a:fontRef idx="minor">
+            <a:schemeClr val="lt1"/>
+          </a:fontRef>
+        </p:style>
+        <p:txBody>
+          <a:bodyPr rtlCol="0" anchor="ctr"/>
+          <a:lstStyle/>
+          <a:p/>
+        </p:txBody>
+      </p:sp>
+      <p:sp>
+        <p:nvSpPr>
+          <p:cNvPr id="23" name="Takeaways number 5"/>
+          <p:cNvSpPr/>
+          <p:nvPr/>
+        </p:nvSpPr>
+        <p:spPr>
+          <a:xfrm>
+            <a:off x="594360" y="4041648"/>
+            <a:ext cx="310896" cy="310896"/>
+          </a:xfrm>
+          <a:prstGeom prst="ellipse">
+            <a:avLst/>
+          </a:prstGeom>
+          <a:solidFill>
+            <a:schemeClr val="tx2"/>
+          </a:solidFill>
+          <a:ln>
+            <a:noFill/>
+          </a:ln>
+          <a:effectLst/>
+        </p:spPr>
+        <p:style>
+          <a:lnRef idx="1">
+            <a:schemeClr val="accent1"/>
+          </a:lnRef>
+          <a:fillRef idx="3">
+            <a:schemeClr val="accent1"/>
+          </a:fillRef>
+          <a:effectRef idx="2">
+            <a:schemeClr val="accent1"/>
+          </a:effectRef>
+          <a:fontRef idx="minor">
+            <a:schemeClr val="lt1"/>
+          </a:fontRef>
+        </p:style>
+        <p:txBody>
+          <a:bodyPr rtlCol="0" anchor="ctr" lIns="0" rIns="0" tIns="0" bIns="0"/>
+          <a:lstStyle/>
+          <a:p>
+            <a:pPr algn="ctr"/>
+            <a:r>
+              <a:rPr sz="1200" b="1" lang="en-GB">
+                <a:solidFill>
+                  <a:schemeClr val="bg1"/>
+                </a:solidFill>
+              </a:rPr>
+              <a:t>5</a:t>
+            </a:r>
+          </a:p>
+        </p:txBody>
+      </p:sp>
+      <p:sp>
+        <p:nvSpPr>
+          <p:cNvPr id="24" name="Takeaways text 5"/>
+          <p:cNvSpPr txBox="1"/>
+          <p:nvPr/>
+        </p:nvSpPr>
+        <p:spPr>
+          <a:xfrm>
+            <a:off x="1051560" y="3904488"/>
+            <a:ext cx="7498080" cy="585216"/>
+          </a:xfrm>
+          <a:prstGeom prst="rect">
+            <a:avLst/>
+          </a:prstGeom>
+          <a:noFill/>
+        </p:spPr>
+        <p:txBody>
+          <a:bodyPr wrap="square" lIns="0" rIns="0" tIns="0" bIns="0" anchor="ctr">
+            <a:noAutofit/>
+          </a:bodyPr>
+          <a:lstStyle/>
+          <a:p>
+            <a:pPr algn="l">
+              <a:spcAft>
+                <a:spcPts val="400"/>
+              </a:spcAft>
+            </a:pPr>
+            <a:r>
+              <a:rPr sz="1200" b="1" lang="en-GB">
+                <a:solidFill>
+                  <a:schemeClr val="tx2"/>
+                </a:solidFill>
+              </a:rPr>
+              <a:t>Covariance </a:t>
+            </a:r>
+            <a:r>
+              <a:rPr sz="1200" b="0" lang="en-GB">
+                <a:solidFill>
+                  <a:schemeClr val="tx1"/>
+                </a:solidFill>
+              </a:rPr>
+              <a:t>gives the direction, correlation the strength (−1 to +1), regression the size</a:t>
+            </a:r>
+          </a:p>
+        </p:txBody>
+      </p:sp>
+      <p:sp>
+        <p:nvSpPr>
+          <p:cNvPr id="25" name="Take next box"/>
+          <p:cNvSpPr/>
+          <p:nvPr/>
+        </p:nvSpPr>
+        <p:spPr>
+          <a:xfrm>
+            <a:off x="457200" y="4572000"/>
+            <a:ext cx="8229600" cy="457200"/>
+          </a:xfrm>
+          <a:prstGeom prst="rect">
+            <a:avLst/>
+          </a:prstGeom>
+          <a:solidFill>
+            <a:schemeClr val="tx2"/>
+          </a:solidFill>
+          <a:ln>
+            <a:noFill/>
+          </a:ln>
+          <a:effectLst/>
+        </p:spPr>
+        <p:style>
+          <a:lnRef idx="1">
+            <a:schemeClr val="accent1"/>
+          </a:lnRef>
+          <a:fillRef idx="3">
+            <a:schemeClr val="accent1"/>
+          </a:fillRef>
+          <a:effectRef idx="2">
+            <a:schemeClr val="accent1"/>
+          </a:effectRef>
+          <a:fontRef idx="minor">
+            <a:schemeClr val="lt1"/>
+          </a:fontRef>
+        </p:style>
+        <p:txBody>
+          <a:bodyPr rtlCol="0" anchor="ctr"/>
+          <a:lstStyle/>
+          <a:p/>
         </p:txBody>
       </p:sp>
       <p:pic>
         <p:nvPicPr>
-          <p:cNvPr id="12" name="Icon ref 1" descr=""/>
+          <p:cNvPr id="26" name="Icon Take next" descr=""/>
           <p:cNvPicPr>
             <a:picLocks noChangeAspect="1"/>
           </p:cNvPicPr>
@@ -31389,8 +32106,8 @@
         </p:blipFill>
         <p:spPr>
           <a:xfrm>
-            <a:off x="4064508" y="1280160"/>
-            <a:ext cx="310896" cy="310896"/>
+            <a:off x="658368" y="4617720"/>
+            <a:ext cx="365760" cy="365760"/>
           </a:xfrm>
           <a:prstGeom prst="rect">
             <a:avLst/>
@@ -31399,213 +32116,14 @@
       </p:pic>
       <p:sp>
         <p:nvSpPr>
-          <p:cNvPr id="13" name="Ref 1 body"/>
-          <p:cNvSpPr/>
-          <p:nvPr/>
-        </p:nvSpPr>
-        <p:spPr>
-          <a:xfrm>
-            <a:off x="457200" y="1645920"/>
-            <a:ext cx="4046220" cy="3429000"/>
-          </a:xfrm>
-          <a:prstGeom prst="rect">
-            <a:avLst/>
-          </a:prstGeom>
-          <a:solidFill>
-            <a:schemeClr val="bg2"/>
-          </a:solidFill>
-          <a:ln>
-            <a:noFill/>
-          </a:ln>
-          <a:effectLst/>
-        </p:spPr>
-        <p:style>
-          <a:lnRef idx="1">
-            <a:schemeClr val="accent1"/>
-          </a:lnRef>
-          <a:fillRef idx="3">
-            <a:schemeClr val="accent1"/>
-          </a:fillRef>
-          <a:effectRef idx="2">
-            <a:schemeClr val="accent1"/>
-          </a:effectRef>
-          <a:fontRef idx="minor">
-            <a:schemeClr val="lt1"/>
-          </a:fontRef>
-        </p:style>
-        <p:txBody>
-          <a:bodyPr rtlCol="0" anchor="ctr"/>
-          <a:lstStyle/>
-          <a:p/>
-        </p:txBody>
-      </p:sp>
-      <p:sp>
-        <p:nvSpPr>
-          <p:cNvPr id="14" name="Ref 1 text"/>
+          <p:cNvPr id="27" name="Take next text"/>
           <p:cNvSpPr txBox="1"/>
           <p:nvPr/>
         </p:nvSpPr>
         <p:spPr>
           <a:xfrm>
-            <a:off x="621792" y="1737360"/>
-            <a:ext cx="3744468" cy="3291840"/>
-          </a:xfrm>
-          <a:prstGeom prst="rect">
-            <a:avLst/>
-          </a:prstGeom>
-          <a:noFill/>
-        </p:spPr>
-        <p:txBody>
-          <a:bodyPr wrap="square" lIns="0" rIns="0" tIns="0" bIns="0" anchor="t">
-            <a:noAutofit/>
-          </a:bodyPr>
-          <a:lstStyle/>
-          <a:p>
-            <a:pPr algn="l">
-              <a:spcAft>
-                <a:spcPts val="600"/>
-              </a:spcAft>
-            </a:pPr>
-            <a:r>
-              <a:rPr sz="1150" b="1" lang="en-GB">
-                <a:solidFill>
-                  <a:schemeClr val="tx2"/>
-                </a:solidFill>
-              </a:rPr>
-              <a:t>Field, A. (2024). </a:t>
-            </a:r>
-            <a:r>
-              <a:rPr sz="1150" b="0" lang="en-GB">
-                <a:solidFill>
-                  <a:schemeClr val="tx1"/>
-                </a:solidFill>
-              </a:rPr>
-              <a:t>Discovering Statistics Using IBM SPSS Statistics, 6th ed. SAGE. Chapters 1 to 2 and 8.</a:t>
-            </a:r>
-          </a:p>
-          <a:p>
-            <a:pPr algn="l">
-              <a:spcAft>
-                <a:spcPts val="600"/>
-              </a:spcAft>
-            </a:pPr>
-            <a:r>
-              <a:rPr sz="1150" b="1" lang="en-GB">
-                <a:solidFill>
-                  <a:schemeClr val="tx2"/>
-                </a:solidFill>
-              </a:rPr>
-              <a:t>Bojinov, I. I., Parzen, M. &amp; Hamilton, P. J. (2025). </a:t>
-            </a:r>
-            <a:r>
-              <a:rPr sz="1150" b="0" lang="en-GB">
-                <a:solidFill>
-                  <a:schemeClr val="tx1"/>
-                </a:solidFill>
-              </a:rPr>
-              <a:t>Linear Regression. HBS note 9-622-100: correlation.</a:t>
-            </a:r>
-          </a:p>
-          <a:p>
-            <a:pPr algn="l">
-              <a:spcAft>
-                <a:spcPts val="600"/>
-              </a:spcAft>
-            </a:pPr>
-            <a:r>
-              <a:rPr sz="1150" b="1" lang="en-GB">
-                <a:solidFill>
-                  <a:schemeClr val="tx2"/>
-                </a:solidFill>
-              </a:rPr>
-              <a:t>Hair, J. F. et al. (2019). </a:t>
-            </a:r>
-            <a:r>
-              <a:rPr sz="1150" b="0" lang="en-GB">
-                <a:solidFill>
-                  <a:schemeClr val="tx1"/>
-                </a:solidFill>
-              </a:rPr>
-              <a:t>Multivariate Data Analysis, 8th ed. Cengage. Chapter 2.</a:t>
-            </a:r>
-          </a:p>
-          <a:p>
-            <a:pPr algn="l">
-              <a:spcAft>
-                <a:spcPts val="600"/>
-              </a:spcAft>
-            </a:pPr>
-            <a:r>
-              <a:rPr sz="1150" b="1" lang="en-GB">
-                <a:solidFill>
-                  <a:schemeClr val="tx2"/>
-                </a:solidFill>
-              </a:rPr>
-              <a:t>Stock, J. H. &amp; Watson, M. W. (2019). </a:t>
-            </a:r>
-            <a:r>
-              <a:rPr sz="1150" b="0" lang="en-GB">
-                <a:solidFill>
-                  <a:schemeClr val="tx1"/>
-                </a:solidFill>
-              </a:rPr>
-              <a:t>Introduction to Econometrics, 4th ed. Pearson. Chapters 2 to 3.</a:t>
-            </a:r>
-          </a:p>
-        </p:txBody>
-      </p:sp>
-      <p:sp>
-        <p:nvSpPr>
-          <p:cNvPr id="15" name="Ref 2 header"/>
-          <p:cNvSpPr/>
-          <p:nvPr/>
-        </p:nvSpPr>
-        <p:spPr>
-          <a:xfrm>
-            <a:off x="4640580" y="1234440"/>
-            <a:ext cx="4046220" cy="411480"/>
-          </a:xfrm>
-          <a:prstGeom prst="rect">
-            <a:avLst/>
-          </a:prstGeom>
-          <a:solidFill>
-            <a:schemeClr val="accent1"/>
-          </a:solidFill>
-          <a:ln>
-            <a:noFill/>
-          </a:ln>
-          <a:effectLst/>
-        </p:spPr>
-        <p:style>
-          <a:lnRef idx="1">
-            <a:schemeClr val="accent1"/>
-          </a:lnRef>
-          <a:fillRef idx="3">
-            <a:schemeClr val="accent1"/>
-          </a:fillRef>
-          <a:effectRef idx="2">
-            <a:schemeClr val="accent1"/>
-          </a:effectRef>
-          <a:fontRef idx="minor">
-            <a:schemeClr val="lt1"/>
-          </a:fontRef>
-        </p:style>
-        <p:txBody>
-          <a:bodyPr rtlCol="0" anchor="ctr"/>
-          <a:lstStyle/>
-          <a:p/>
-        </p:txBody>
-      </p:sp>
-      <p:sp>
-        <p:nvSpPr>
-          <p:cNvPr id="16" name="Ref 2 heading"/>
-          <p:cNvSpPr txBox="1"/>
-          <p:nvPr/>
-        </p:nvSpPr>
-        <p:spPr>
-          <a:xfrm>
-            <a:off x="4777740" y="1234440"/>
-            <a:ext cx="3360420" cy="411480"/>
+            <a:off x="1207008" y="4572000"/>
+            <a:ext cx="7315200" cy="457200"/>
           </a:xfrm>
           <a:prstGeom prst="rect">
             <a:avLst/>
@@ -31624,194 +32142,20 @@
               </a:spcAft>
             </a:pPr>
             <a:r>
-              <a:rPr sz="1500" b="1" lang="en-GB">
+              <a:rPr sz="1200" b="1" lang="en-GB">
                 <a:solidFill>
                   <a:schemeClr val="bg1"/>
                 </a:solidFill>
-                <a:latin typeface="+mj-lt"/>
-              </a:rPr>
-              <a:t>Online</a:t>
-            </a:r>
-          </a:p>
-        </p:txBody>
-      </p:sp>
-      <p:pic>
-        <p:nvPicPr>
-          <p:cNvPr id="17" name="Icon ref 2" descr=""/>
-          <p:cNvPicPr>
-            <a:picLocks noChangeAspect="1"/>
-          </p:cNvPicPr>
-          <p:nvPr/>
-        </p:nvPicPr>
-        <p:blipFill>
-          <a:blip r:embed="rId4"/>
-          <a:stretch>
-            <a:fillRect/>
-          </a:stretch>
-        </p:blipFill>
-        <p:spPr>
-          <a:xfrm>
-            <a:off x="8247888" y="1280160"/>
-            <a:ext cx="310896" cy="310896"/>
-          </a:xfrm>
-          <a:prstGeom prst="rect">
-            <a:avLst/>
-          </a:prstGeom>
-        </p:spPr>
-      </p:pic>
-      <p:sp>
-        <p:nvSpPr>
-          <p:cNvPr id="18" name="Ref 2 body"/>
-          <p:cNvSpPr/>
-          <p:nvPr/>
-        </p:nvSpPr>
-        <p:spPr>
-          <a:xfrm>
-            <a:off x="4640580" y="1645920"/>
-            <a:ext cx="4046220" cy="3429000"/>
-          </a:xfrm>
-          <a:prstGeom prst="rect">
-            <a:avLst/>
-          </a:prstGeom>
-          <a:solidFill>
-            <a:schemeClr val="bg2"/>
-          </a:solidFill>
-          <a:ln>
-            <a:noFill/>
-          </a:ln>
-          <a:effectLst/>
-        </p:spPr>
-        <p:style>
-          <a:lnRef idx="1">
-            <a:schemeClr val="accent1"/>
-          </a:lnRef>
-          <a:fillRef idx="3">
-            <a:schemeClr val="accent1"/>
-          </a:fillRef>
-          <a:effectRef idx="2">
-            <a:schemeClr val="accent1"/>
-          </a:effectRef>
-          <a:fontRef idx="minor">
-            <a:schemeClr val="lt1"/>
-          </a:fontRef>
-        </p:style>
-        <p:txBody>
-          <a:bodyPr rtlCol="0" anchor="ctr"/>
-          <a:lstStyle/>
-          <a:p/>
-        </p:txBody>
-      </p:sp>
-      <p:sp>
-        <p:nvSpPr>
-          <p:cNvPr id="19" name="Ref 2 text"/>
-          <p:cNvSpPr txBox="1"/>
-          <p:nvPr/>
-        </p:nvSpPr>
-        <p:spPr>
-          <a:xfrm>
-            <a:off x="4805172" y="1737360"/>
-            <a:ext cx="3744468" cy="3291840"/>
-          </a:xfrm>
-          <a:prstGeom prst="rect">
-            <a:avLst/>
-          </a:prstGeom>
-          <a:noFill/>
-        </p:spPr>
-        <p:txBody>
-          <a:bodyPr wrap="square" lIns="0" rIns="0" tIns="0" bIns="0" anchor="t">
-            <a:noAutofit/>
-          </a:bodyPr>
-          <a:lstStyle/>
-          <a:p>
-            <a:pPr algn="l">
-              <a:spcAft>
-                <a:spcPts val="600"/>
-              </a:spcAft>
-            </a:pPr>
-            <a:r>
-              <a:rPr sz="1150" b="1" lang="en-GB">
-                <a:solidFill>
-                  <a:schemeClr val="tx2"/>
-                </a:solidFill>
-              </a:rPr>
-              <a:t>Seeing Theory. </a:t>
-            </a:r>
-            <a:r>
-              <a:rPr sz="1150" b="0" lang="en-GB">
-                <a:solidFill>
-                  <a:schemeClr val="tx1"/>
-                </a:solidFill>
-              </a:rPr>
-              <a:t>Brown University: interactive visual introduction to probability and statistics (free).</a:t>
-            </a:r>
-          </a:p>
-          <a:p>
-            <a:pPr algn="l">
-              <a:spcAft>
-                <a:spcPts val="600"/>
-              </a:spcAft>
-            </a:pPr>
-            <a:r>
-              <a:rPr sz="1150" b="1" lang="en-GB">
-                <a:solidFill>
-                  <a:schemeClr val="tx2"/>
-                </a:solidFill>
-              </a:rPr>
-              <a:t>StatQuest. </a:t>
-            </a:r>
-            <a:r>
-              <a:rPr sz="1150" b="0" lang="en-GB">
-                <a:solidFill>
-                  <a:schemeClr val="tx1"/>
-                </a:solidFill>
-              </a:rPr>
-              <a:t>Videos on the normal distribution, standard deviation vs standard error, covariance and correlation (free).</a:t>
-            </a:r>
-          </a:p>
-          <a:p>
-            <a:pPr algn="l">
-              <a:spcAft>
-                <a:spcPts val="600"/>
-              </a:spcAft>
-            </a:pPr>
-            <a:r>
-              <a:rPr sz="1150" b="1" lang="en-GB">
-                <a:solidFill>
-                  <a:schemeClr val="tx2"/>
-                </a:solidFill>
-              </a:rPr>
-              <a:t>polars documentation. </a:t>
-            </a:r>
-            <a:r>
-              <a:rPr sz="1150" b="0" lang="en-GB">
-                <a:solidFill>
-                  <a:schemeClr val="tx1"/>
-                </a:solidFill>
-              </a:rPr>
-              <a:t>mean, median, std, cov, corr.</a:t>
-            </a:r>
-          </a:p>
-          <a:p>
-            <a:pPr algn="l">
-              <a:spcAft>
-                <a:spcPts val="600"/>
-              </a:spcAft>
-            </a:pPr>
-            <a:r>
-              <a:rPr sz="1150" b="1" lang="en-GB">
-                <a:solidFill>
-                  <a:schemeClr val="tx2"/>
-                </a:solidFill>
-              </a:rPr>
-              <a:t>Gelman, Hill &amp; Vehtari (2020). </a:t>
-            </a:r>
-            <a:r>
-              <a:rPr sz="1150" b="0" lang="en-GB">
-                <a:solidFill>
-                  <a:schemeClr val="tx1"/>
-                </a:solidFill>
-              </a:rPr>
-              <a:t>Regression and Other Stories, ch. 3 to 4 (free PDF).</a:t>
+              </a:rPr>
+              <a:t>Next: </a:t>
+            </a:r>
+            <a:r>
+              <a:rPr sz="1200" b="0" lang="en-GB">
+                <a:solidFill>
+                  <a:schemeClr val="bg1"/>
+                </a:solidFill>
+              </a:rPr>
+              <a:t>linear regression on real chocolate data.</a:t>
             </a:r>
           </a:p>
         </p:txBody>
@@ -31836,12 +32180,12 @@
       <p:grpSpPr/>
       <p:sp>
         <p:nvSpPr>
-          <p:cNvPr id="9" name="Fußzeilenplatzhalter 8"/>
+          <p:cNvPr id="3" name="Title 2"/>
           <p:cNvSpPr>
             <a:spLocks noGrp="1"/>
           </p:cNvSpPr>
           <p:nvPr>
-            <p:ph type="ftr" sz="quarter" idx="12"/>
+            <p:ph type="title"/>
           </p:nvPr>
         </p:nvSpPr>
         <p:spPr/>
@@ -31850,20 +32194,42 @@
           <a:lstStyle/>
           <a:p>
             <a:r>
-              <a:rPr lang="en-GB"/>
-              <a:t>International Marketing Analytics · WT 2026/27</a:t>
-            </a:r>
-          </a:p>
-        </p:txBody>
-      </p:sp>
-      <p:sp>
-        <p:nvSpPr>
-          <p:cNvPr id="10" name="Foliennummernplatzhalter 9"/>
+              <a:rPr sz="1600" lang="en-GB"/>
+              <a:t>References</a:t>
+            </a:r>
+          </a:p>
+        </p:txBody>
+      </p:sp>
+      <p:sp>
+        <p:nvSpPr>
+          <p:cNvPr id="8" name="Fußzeilenplatzhalter 7"/>
           <p:cNvSpPr>
             <a:spLocks noGrp="1"/>
           </p:cNvSpPr>
           <p:nvPr>
-            <p:ph type="sldNum" sz="quarter" idx="13"/>
+            <p:ph type="ftr" sz="quarter" idx="11"/>
+          </p:nvPr>
+        </p:nvSpPr>
+        <p:spPr/>
+        <p:txBody>
+          <a:bodyPr/>
+          <a:lstStyle/>
+          <a:p>
+            <a:r>
+              <a:rPr lang="en-GB"/>
+              <a:t>International Marketing Analytics · WT 2026/27</a:t>
+            </a:r>
+          </a:p>
+        </p:txBody>
+      </p:sp>
+      <p:sp>
+        <p:nvSpPr>
+          <p:cNvPr id="9" name="Foliennummernplatzhalter 8"/>
+          <p:cNvSpPr>
+            <a:spLocks noGrp="1"/>
+          </p:cNvSpPr>
+          <p:nvPr>
+            <p:ph type="sldNum" sz="quarter" idx="12"/>
           </p:nvPr>
         </p:nvSpPr>
         <p:spPr/>
@@ -31880,6 +32246,530 @@
               <a:t>‹Nr.›</a:t>
             </a:fld>
             <a:endParaRPr lang="en-GB" dirty="0"/>
+          </a:p>
+        </p:txBody>
+      </p:sp>
+      <p:sp>
+        <p:nvSpPr>
+          <p:cNvPr id="10" name="Ref 1 header"/>
+          <p:cNvSpPr/>
+          <p:nvPr/>
+        </p:nvSpPr>
+        <p:spPr>
+          <a:xfrm>
+            <a:off x="457200" y="1234440"/>
+            <a:ext cx="4046220" cy="411480"/>
+          </a:xfrm>
+          <a:prstGeom prst="rect">
+            <a:avLst/>
+          </a:prstGeom>
+          <a:solidFill>
+            <a:schemeClr val="accent1"/>
+          </a:solidFill>
+          <a:ln>
+            <a:noFill/>
+          </a:ln>
+          <a:effectLst/>
+        </p:spPr>
+        <p:style>
+          <a:lnRef idx="1">
+            <a:schemeClr val="accent1"/>
+          </a:lnRef>
+          <a:fillRef idx="3">
+            <a:schemeClr val="accent1"/>
+          </a:fillRef>
+          <a:effectRef idx="2">
+            <a:schemeClr val="accent1"/>
+          </a:effectRef>
+          <a:fontRef idx="minor">
+            <a:schemeClr val="lt1"/>
+          </a:fontRef>
+        </p:style>
+        <p:txBody>
+          <a:bodyPr rtlCol="0" anchor="ctr"/>
+          <a:lstStyle/>
+          <a:p/>
+        </p:txBody>
+      </p:sp>
+      <p:sp>
+        <p:nvSpPr>
+          <p:cNvPr id="11" name="Ref 1 heading"/>
+          <p:cNvSpPr txBox="1"/>
+          <p:nvPr/>
+        </p:nvSpPr>
+        <p:spPr>
+          <a:xfrm>
+            <a:off x="594360" y="1234440"/>
+            <a:ext cx="3360420" cy="411480"/>
+          </a:xfrm>
+          <a:prstGeom prst="rect">
+            <a:avLst/>
+          </a:prstGeom>
+          <a:noFill/>
+        </p:spPr>
+        <p:txBody>
+          <a:bodyPr wrap="square" lIns="0" rIns="0" tIns="0" bIns="0" anchor="ctr">
+            <a:noAutofit/>
+          </a:bodyPr>
+          <a:lstStyle/>
+          <a:p>
+            <a:pPr algn="l">
+              <a:spcAft>
+                <a:spcPts val="400"/>
+              </a:spcAft>
+            </a:pPr>
+            <a:r>
+              <a:rPr sz="1500" b="1" lang="en-GB">
+                <a:solidFill>
+                  <a:schemeClr val="bg1"/>
+                </a:solidFill>
+                <a:latin typeface="+mj-lt"/>
+              </a:rPr>
+              <a:t>Books and readings</a:t>
+            </a:r>
+          </a:p>
+        </p:txBody>
+      </p:sp>
+      <p:pic>
+        <p:nvPicPr>
+          <p:cNvPr id="12" name="Icon ref 1" descr=""/>
+          <p:cNvPicPr>
+            <a:picLocks noChangeAspect="1"/>
+          </p:cNvPicPr>
+          <p:nvPr/>
+        </p:nvPicPr>
+        <p:blipFill>
+          <a:blip r:embed="rId3"/>
+          <a:stretch>
+            <a:fillRect/>
+          </a:stretch>
+        </p:blipFill>
+        <p:spPr>
+          <a:xfrm>
+            <a:off x="4064508" y="1280160"/>
+            <a:ext cx="310896" cy="310896"/>
+          </a:xfrm>
+          <a:prstGeom prst="rect">
+            <a:avLst/>
+          </a:prstGeom>
+        </p:spPr>
+      </p:pic>
+      <p:sp>
+        <p:nvSpPr>
+          <p:cNvPr id="13" name="Ref 1 body"/>
+          <p:cNvSpPr/>
+          <p:nvPr/>
+        </p:nvSpPr>
+        <p:spPr>
+          <a:xfrm>
+            <a:off x="457200" y="1645920"/>
+            <a:ext cx="4046220" cy="3429000"/>
+          </a:xfrm>
+          <a:prstGeom prst="rect">
+            <a:avLst/>
+          </a:prstGeom>
+          <a:solidFill>
+            <a:schemeClr val="bg2"/>
+          </a:solidFill>
+          <a:ln>
+            <a:noFill/>
+          </a:ln>
+          <a:effectLst/>
+        </p:spPr>
+        <p:style>
+          <a:lnRef idx="1">
+            <a:schemeClr val="accent1"/>
+          </a:lnRef>
+          <a:fillRef idx="3">
+            <a:schemeClr val="accent1"/>
+          </a:fillRef>
+          <a:effectRef idx="2">
+            <a:schemeClr val="accent1"/>
+          </a:effectRef>
+          <a:fontRef idx="minor">
+            <a:schemeClr val="lt1"/>
+          </a:fontRef>
+        </p:style>
+        <p:txBody>
+          <a:bodyPr rtlCol="0" anchor="ctr"/>
+          <a:lstStyle/>
+          <a:p/>
+        </p:txBody>
+      </p:sp>
+      <p:sp>
+        <p:nvSpPr>
+          <p:cNvPr id="14" name="Ref 1 text"/>
+          <p:cNvSpPr txBox="1"/>
+          <p:nvPr/>
+        </p:nvSpPr>
+        <p:spPr>
+          <a:xfrm>
+            <a:off x="621792" y="1737360"/>
+            <a:ext cx="3744468" cy="3291840"/>
+          </a:xfrm>
+          <a:prstGeom prst="rect">
+            <a:avLst/>
+          </a:prstGeom>
+          <a:noFill/>
+        </p:spPr>
+        <p:txBody>
+          <a:bodyPr wrap="square" lIns="0" rIns="0" tIns="0" bIns="0" anchor="t">
+            <a:noAutofit/>
+          </a:bodyPr>
+          <a:lstStyle/>
+          <a:p>
+            <a:pPr algn="l">
+              <a:spcAft>
+                <a:spcPts val="600"/>
+              </a:spcAft>
+            </a:pPr>
+            <a:r>
+              <a:rPr sz="1150" b="1" lang="en-GB">
+                <a:solidFill>
+                  <a:schemeClr val="tx2"/>
+                </a:solidFill>
+              </a:rPr>
+              <a:t>Field, A. (2024). </a:t>
+            </a:r>
+            <a:r>
+              <a:rPr sz="1150" b="0" lang="en-GB">
+                <a:solidFill>
+                  <a:schemeClr val="tx1"/>
+                </a:solidFill>
+              </a:rPr>
+              <a:t>Discovering Statistics Using IBM SPSS Statistics, 6th ed. SAGE. Chapters 1 to 2 and 8.</a:t>
+            </a:r>
+          </a:p>
+          <a:p>
+            <a:pPr algn="l">
+              <a:spcAft>
+                <a:spcPts val="600"/>
+              </a:spcAft>
+            </a:pPr>
+            <a:r>
+              <a:rPr sz="1150" b="1" lang="en-GB">
+                <a:solidFill>
+                  <a:schemeClr val="tx2"/>
+                </a:solidFill>
+              </a:rPr>
+              <a:t>Bojinov, I. I., Parzen, M. &amp; Hamilton, P. J. (2025). </a:t>
+            </a:r>
+            <a:r>
+              <a:rPr sz="1150" b="0" lang="en-GB">
+                <a:solidFill>
+                  <a:schemeClr val="tx1"/>
+                </a:solidFill>
+              </a:rPr>
+              <a:t>Linear Regression. HBS note 9-622-100: correlation.</a:t>
+            </a:r>
+          </a:p>
+          <a:p>
+            <a:pPr algn="l">
+              <a:spcAft>
+                <a:spcPts val="600"/>
+              </a:spcAft>
+            </a:pPr>
+            <a:r>
+              <a:rPr sz="1150" b="1" lang="en-GB">
+                <a:solidFill>
+                  <a:schemeClr val="tx2"/>
+                </a:solidFill>
+              </a:rPr>
+              <a:t>Hair, J. F. et al. (2019). </a:t>
+            </a:r>
+            <a:r>
+              <a:rPr sz="1150" b="0" lang="en-GB">
+                <a:solidFill>
+                  <a:schemeClr val="tx1"/>
+                </a:solidFill>
+              </a:rPr>
+              <a:t>Multivariate Data Analysis, 8th ed. Cengage. Chapter 2.</a:t>
+            </a:r>
+          </a:p>
+          <a:p>
+            <a:pPr algn="l">
+              <a:spcAft>
+                <a:spcPts val="600"/>
+              </a:spcAft>
+            </a:pPr>
+            <a:r>
+              <a:rPr sz="1150" b="1" lang="en-GB">
+                <a:solidFill>
+                  <a:schemeClr val="tx2"/>
+                </a:solidFill>
+              </a:rPr>
+              <a:t>Stock, J. H. &amp; Watson, M. W. (2019). </a:t>
+            </a:r>
+            <a:r>
+              <a:rPr sz="1150" b="0" lang="en-GB">
+                <a:solidFill>
+                  <a:schemeClr val="tx1"/>
+                </a:solidFill>
+              </a:rPr>
+              <a:t>Introduction to Econometrics, 4th ed. Pearson. Chapters 2 to 3.</a:t>
+            </a:r>
+          </a:p>
+        </p:txBody>
+      </p:sp>
+      <p:sp>
+        <p:nvSpPr>
+          <p:cNvPr id="15" name="Ref 2 header"/>
+          <p:cNvSpPr/>
+          <p:nvPr/>
+        </p:nvSpPr>
+        <p:spPr>
+          <a:xfrm>
+            <a:off x="4640580" y="1234440"/>
+            <a:ext cx="4046220" cy="411480"/>
+          </a:xfrm>
+          <a:prstGeom prst="rect">
+            <a:avLst/>
+          </a:prstGeom>
+          <a:solidFill>
+            <a:schemeClr val="accent1"/>
+          </a:solidFill>
+          <a:ln>
+            <a:noFill/>
+          </a:ln>
+          <a:effectLst/>
+        </p:spPr>
+        <p:style>
+          <a:lnRef idx="1">
+            <a:schemeClr val="accent1"/>
+          </a:lnRef>
+          <a:fillRef idx="3">
+            <a:schemeClr val="accent1"/>
+          </a:fillRef>
+          <a:effectRef idx="2">
+            <a:schemeClr val="accent1"/>
+          </a:effectRef>
+          <a:fontRef idx="minor">
+            <a:schemeClr val="lt1"/>
+          </a:fontRef>
+        </p:style>
+        <p:txBody>
+          <a:bodyPr rtlCol="0" anchor="ctr"/>
+          <a:lstStyle/>
+          <a:p/>
+        </p:txBody>
+      </p:sp>
+      <p:sp>
+        <p:nvSpPr>
+          <p:cNvPr id="16" name="Ref 2 heading"/>
+          <p:cNvSpPr txBox="1"/>
+          <p:nvPr/>
+        </p:nvSpPr>
+        <p:spPr>
+          <a:xfrm>
+            <a:off x="4777740" y="1234440"/>
+            <a:ext cx="3360420" cy="411480"/>
+          </a:xfrm>
+          <a:prstGeom prst="rect">
+            <a:avLst/>
+          </a:prstGeom>
+          <a:noFill/>
+        </p:spPr>
+        <p:txBody>
+          <a:bodyPr wrap="square" lIns="0" rIns="0" tIns="0" bIns="0" anchor="ctr">
+            <a:noAutofit/>
+          </a:bodyPr>
+          <a:lstStyle/>
+          <a:p>
+            <a:pPr algn="l">
+              <a:spcAft>
+                <a:spcPts val="400"/>
+              </a:spcAft>
+            </a:pPr>
+            <a:r>
+              <a:rPr sz="1500" b="1" lang="en-GB">
+                <a:solidFill>
+                  <a:schemeClr val="bg1"/>
+                </a:solidFill>
+                <a:latin typeface="+mj-lt"/>
+              </a:rPr>
+              <a:t>Online</a:t>
+            </a:r>
+          </a:p>
+        </p:txBody>
+      </p:sp>
+      <p:pic>
+        <p:nvPicPr>
+          <p:cNvPr id="17" name="Icon ref 2" descr=""/>
+          <p:cNvPicPr>
+            <a:picLocks noChangeAspect="1"/>
+          </p:cNvPicPr>
+          <p:nvPr/>
+        </p:nvPicPr>
+        <p:blipFill>
+          <a:blip r:embed="rId4"/>
+          <a:stretch>
+            <a:fillRect/>
+          </a:stretch>
+        </p:blipFill>
+        <p:spPr>
+          <a:xfrm>
+            <a:off x="8247888" y="1280160"/>
+            <a:ext cx="310896" cy="310896"/>
+          </a:xfrm>
+          <a:prstGeom prst="rect">
+            <a:avLst/>
+          </a:prstGeom>
+        </p:spPr>
+      </p:pic>
+      <p:sp>
+        <p:nvSpPr>
+          <p:cNvPr id="18" name="Ref 2 body"/>
+          <p:cNvSpPr/>
+          <p:nvPr/>
+        </p:nvSpPr>
+        <p:spPr>
+          <a:xfrm>
+            <a:off x="4640580" y="1645920"/>
+            <a:ext cx="4046220" cy="3429000"/>
+          </a:xfrm>
+          <a:prstGeom prst="rect">
+            <a:avLst/>
+          </a:prstGeom>
+          <a:solidFill>
+            <a:schemeClr val="bg2"/>
+          </a:solidFill>
+          <a:ln>
+            <a:noFill/>
+          </a:ln>
+          <a:effectLst/>
+        </p:spPr>
+        <p:style>
+          <a:lnRef idx="1">
+            <a:schemeClr val="accent1"/>
+          </a:lnRef>
+          <a:fillRef idx="3">
+            <a:schemeClr val="accent1"/>
+          </a:fillRef>
+          <a:effectRef idx="2">
+            <a:schemeClr val="accent1"/>
+          </a:effectRef>
+          <a:fontRef idx="minor">
+            <a:schemeClr val="lt1"/>
+          </a:fontRef>
+        </p:style>
+        <p:txBody>
+          <a:bodyPr rtlCol="0" anchor="ctr"/>
+          <a:lstStyle/>
+          <a:p/>
+        </p:txBody>
+      </p:sp>
+      <p:sp>
+        <p:nvSpPr>
+          <p:cNvPr id="19" name="Ref 2 text"/>
+          <p:cNvSpPr txBox="1"/>
+          <p:nvPr/>
+        </p:nvSpPr>
+        <p:spPr>
+          <a:xfrm>
+            <a:off x="4805172" y="1737360"/>
+            <a:ext cx="3744468" cy="3291840"/>
+          </a:xfrm>
+          <a:prstGeom prst="rect">
+            <a:avLst/>
+          </a:prstGeom>
+          <a:noFill/>
+        </p:spPr>
+        <p:txBody>
+          <a:bodyPr wrap="square" lIns="0" rIns="0" tIns="0" bIns="0" anchor="t">
+            <a:noAutofit/>
+          </a:bodyPr>
+          <a:lstStyle/>
+          <a:p>
+            <a:pPr algn="l">
+              <a:spcAft>
+                <a:spcPts val="600"/>
+              </a:spcAft>
+            </a:pPr>
+            <a:r>
+              <a:rPr sz="1150" b="1" lang="en-GB">
+                <a:solidFill>
+                  <a:schemeClr val="tx2"/>
+                </a:solidFill>
+              </a:rPr>
+              <a:t>Seeing Theory. </a:t>
+            </a:r>
+            <a:r>
+              <a:rPr sz="1150" b="0" lang="en-GB">
+                <a:solidFill>
+                  <a:schemeClr val="tx1"/>
+                </a:solidFill>
+              </a:rPr>
+              <a:t>Brown University: interactive visual introduction to probability and statistics (free).</a:t>
+            </a:r>
+          </a:p>
+          <a:p>
+            <a:pPr algn="l">
+              <a:spcAft>
+                <a:spcPts val="600"/>
+              </a:spcAft>
+            </a:pPr>
+            <a:r>
+              <a:rPr sz="1150" b="1" lang="en-GB">
+                <a:solidFill>
+                  <a:schemeClr val="tx2"/>
+                </a:solidFill>
+              </a:rPr>
+              <a:t>StatQuest. </a:t>
+            </a:r>
+            <a:r>
+              <a:rPr sz="1150" b="0" lang="en-GB">
+                <a:solidFill>
+                  <a:schemeClr val="tx1"/>
+                </a:solidFill>
+              </a:rPr>
+              <a:t>Videos on the normal distribution, standard deviation vs standard error, covariance and correlation (free).</a:t>
+            </a:r>
+          </a:p>
+          <a:p>
+            <a:pPr algn="l">
+              <a:spcAft>
+                <a:spcPts val="600"/>
+              </a:spcAft>
+            </a:pPr>
+            <a:r>
+              <a:rPr sz="1150" b="1" lang="en-GB">
+                <a:solidFill>
+                  <a:schemeClr val="tx2"/>
+                </a:solidFill>
+              </a:rPr>
+              <a:t>polars documentation. </a:t>
+            </a:r>
+            <a:r>
+              <a:rPr sz="1150" b="0" lang="en-GB">
+                <a:solidFill>
+                  <a:schemeClr val="tx1"/>
+                </a:solidFill>
+              </a:rPr>
+              <a:t>mean, median, std, cov, corr.</a:t>
+            </a:r>
+          </a:p>
+          <a:p>
+            <a:pPr algn="l">
+              <a:spcAft>
+                <a:spcPts val="600"/>
+              </a:spcAft>
+            </a:pPr>
+            <a:r>
+              <a:rPr sz="1150" b="1" lang="en-GB">
+                <a:solidFill>
+                  <a:schemeClr val="tx2"/>
+                </a:solidFill>
+              </a:rPr>
+              <a:t>Gelman, Hill &amp; Vehtari (2020). </a:t>
+            </a:r>
+            <a:r>
+              <a:rPr sz="1150" b="0" lang="en-GB">
+                <a:solidFill>
+                  <a:schemeClr val="tx1"/>
+                </a:solidFill>
+              </a:rPr>
+              <a:t>Regression and Other Stories, ch. 3 to 4 (free PDF).</a:t>
+            </a:r>
           </a:p>
         </p:txBody>
       </p:sp>
@@ -34559,6 +35449,73 @@
               </a:rPr>
               <a:t>every number today can be checked with a calculator, then in Python.</a:t>
             </a:r>
+          </a:p>
+        </p:txBody>
+      </p:sp>
+    </p:spTree>
+  </p:cSld>
+  <p:clrMapOvr>
+    <a:masterClrMapping/>
+  </p:clrMapOvr>
+</p:sld>
+</file>
+
+<file path=ppt/slides/slide30.xml><?xml version="1.0" encoding="utf-8"?>
+<p:sld xmlns:a="http://schemas.openxmlformats.org/drawingml/2006/main" xmlns:p="http://schemas.openxmlformats.org/presentationml/2006/main" xmlns:r="http://schemas.openxmlformats.org/officeDocument/2006/relationships">
+  <p:cSld>
+    <p:spTree>
+      <p:nvGrpSpPr>
+        <p:cNvPr id="1" name=""/>
+        <p:cNvGrpSpPr/>
+        <p:nvPr/>
+      </p:nvGrpSpPr>
+      <p:grpSpPr/>
+      <p:sp>
+        <p:nvSpPr>
+          <p:cNvPr id="9" name="Fußzeilenplatzhalter 8"/>
+          <p:cNvSpPr>
+            <a:spLocks noGrp="1"/>
+          </p:cNvSpPr>
+          <p:nvPr>
+            <p:ph type="ftr" sz="quarter" idx="12"/>
+          </p:nvPr>
+        </p:nvSpPr>
+        <p:spPr/>
+        <p:txBody>
+          <a:bodyPr/>
+          <a:lstStyle/>
+          <a:p>
+            <a:r>
+              <a:rPr lang="en-GB"/>
+              <a:t>International Marketing Analytics · WT 2026/27</a:t>
+            </a:r>
+          </a:p>
+        </p:txBody>
+      </p:sp>
+      <p:sp>
+        <p:nvSpPr>
+          <p:cNvPr id="10" name="Foliennummernplatzhalter 9"/>
+          <p:cNvSpPr>
+            <a:spLocks noGrp="1"/>
+          </p:cNvSpPr>
+          <p:nvPr>
+            <p:ph type="sldNum" sz="quarter" idx="13"/>
+          </p:nvPr>
+        </p:nvSpPr>
+        <p:spPr/>
+        <p:txBody>
+          <a:bodyPr/>
+          <a:lstStyle/>
+          <a:p>
+            <a:r>
+              <a:rPr lang="en-GB" dirty="0"/>
+              <a:t>Page </a:t>
+            </a:r>
+            <a:fld id="{BE3DC40E-DBBE-4E2D-9EEC-FBF0DA0E9179}" type="slidenum">
+              <a:rPr lang="en-GB" smtClean="0"/>
+              <a:t>‹Nr.›</a:t>
+            </a:fld>
+            <a:endParaRPr lang="en-GB" dirty="0"/>
           </a:p>
         </p:txBody>
       </p:sp>

</xml_diff>